<commit_message>
The light title as the brand's template draws it; templates with Closing and Title Slide (light)
- `title=light` (themeoptions): text in the foreground role and the wave lines alone, the
  white field showing between them, as UCAR Communications' NSF NCAR template (slide 4)
  and Ben's sample decks; HTML had light-blue bands and other text colors, the PDF's closing
  light-blue bands. A light title over a photo is unchanged (white field and veil, blue lines).
- The four reference templates regenerated by the framework's livery_template.py: each now
  carries a `Closing` layout (the themes' closing slide) and `Title Slide (light)`, which
  pandoc never picks and the framework's slide_layout.py points slides at.

Parity: 201 of 202 PDF pages pixel-identical; template-light page 19 (the light closing)
loses its bands, as intended. Version 3.2.0.

Co-Authored-By: Claude Opus 5.5 <noreply@anthropic.com>
Claude-Session: https://claude.ai/code/session_01QxTZPtUJESWqMyXE15JCRv
</commit_message>
<xml_diff>
--- a/_extensions/engine/liveries/ncar/template.pptx
+++ b/_extensions/engine/liveries/ncar/template.pptx
@@ -2167,6 +2167,978 @@
 </p:sldLayout>
 </file>
 
+<file path=ppt/slideLayouts/slideLayout8.xml><?xml version="1.0" encoding="utf-8"?>
+<p:sldLayout xmlns:a="http://schemas.openxmlformats.org/drawingml/2006/main" xmlns:r="http://schemas.openxmlformats.org/officeDocument/2006/relationships" xmlns:p="http://schemas.openxmlformats.org/presentationml/2006/main" type="obj" preserve="1" showMasterSp="0">
+  <p:cSld name="Closing">
+    <p:bg>
+      <p:bgPr>
+        <a:solidFill>
+          <a:schemeClr val="tx2"/>
+        </a:solidFill>
+        <a:effectLst/>
+      </p:bgPr>
+    </p:bg>
+    <p:spTree>
+      <p:nvGrpSpPr>
+        <p:cNvPr id="1" name=""/>
+        <p:cNvGrpSpPr/>
+        <p:nvPr/>
+      </p:nvGrpSpPr>
+      <p:grpSpPr>
+        <a:xfrm>
+          <a:off x="0" y="0"/>
+          <a:ext cx="0" cy="0"/>
+          <a:chOff x="0" y="0"/>
+          <a:chExt cx="0" cy="0"/>
+        </a:xfrm>
+      </p:grpSpPr>
+      <p:sp>
+        <p:nvSpPr>
+          <p:cNvPr id="11" name="Wave band 1"/>
+          <p:cNvSpPr/>
+          <p:nvPr userDrawn="1"/>
+        </p:nvSpPr>
+        <p:spPr>
+          <a:xfrm>
+            <a:off x="0" y="0"/>
+            <a:ext cx="12192000" cy="6858000"/>
+          </a:xfrm>
+          <a:custGeom>
+            <a:avLst/>
+            <a:gdLst/>
+            <a:ahLst/>
+            <a:cxnLst/>
+            <a:rect l="0" t="0" r="r" b="b"/>
+            <a:pathLst>
+              <a:path w="16000" h="9000" stroke="0">
+                <a:moveTo>
+                  <a:pt x="10979" y="0"/>
+                </a:moveTo>
+                <a:cubicBezTo>
+                  <a:pt x="11339" y="1778"/>
+                  <a:pt x="12909" y="4468"/>
+                  <a:pt x="12909" y="6089"/>
+                </a:cubicBezTo>
+                <a:cubicBezTo>
+                  <a:pt x="12909" y="7867"/>
+                  <a:pt x="12410" y="8713"/>
+                  <a:pt x="12278" y="9000"/>
+                </a:cubicBezTo>
+                <a:lnTo>
+                  <a:pt x="12800" y="9000"/>
+                </a:lnTo>
+                <a:cubicBezTo>
+                  <a:pt x="13258" y="8249"/>
+                  <a:pt x="13712" y="7476"/>
+                  <a:pt x="13712" y="5781"/>
+                </a:cubicBezTo>
+                <a:cubicBezTo>
+                  <a:pt x="13712" y="4272"/>
+                  <a:pt x="11843" y="1425"/>
+                  <a:pt x="11421" y="0"/>
+                </a:cubicBezTo>
+                <a:close/>
+              </a:path>
+            </a:pathLst>
+          </a:custGeom>
+          <a:solidFill>
+            <a:schemeClr val="accent1">
+              <a:alpha val="18000"/>
+            </a:schemeClr>
+          </a:solidFill>
+          <a:ln>
+            <a:noFill/>
+          </a:ln>
+        </p:spPr>
+      </p:sp>
+      <p:sp>
+        <p:nvSpPr>
+          <p:cNvPr id="12" name="Wave band 2"/>
+          <p:cNvSpPr/>
+          <p:nvPr userDrawn="1"/>
+        </p:nvSpPr>
+        <p:spPr>
+          <a:xfrm>
+            <a:off x="0" y="0"/>
+            <a:ext cx="12192000" cy="6858000"/>
+          </a:xfrm>
+          <a:custGeom>
+            <a:avLst/>
+            <a:gdLst/>
+            <a:ahLst/>
+            <a:cxnLst/>
+            <a:rect l="0" t="0" r="r" b="b"/>
+            <a:pathLst>
+              <a:path w="16000" h="9000" stroke="0">
+                <a:moveTo>
+                  <a:pt x="11421" y="0"/>
+                </a:moveTo>
+                <a:cubicBezTo>
+                  <a:pt x="11843" y="1425"/>
+                  <a:pt x="13712" y="4272"/>
+                  <a:pt x="13712" y="5781"/>
+                </a:cubicBezTo>
+                <a:cubicBezTo>
+                  <a:pt x="13712" y="7476"/>
+                  <a:pt x="13258" y="8249"/>
+                  <a:pt x="12800" y="9000"/>
+                </a:cubicBezTo>
+                <a:lnTo>
+                  <a:pt x="13312" y="9000"/>
+                </a:lnTo>
+                <a:cubicBezTo>
+                  <a:pt x="13822" y="8320"/>
+                  <a:pt x="14517" y="7418"/>
+                  <a:pt x="14517" y="5564"/>
+                </a:cubicBezTo>
+                <a:cubicBezTo>
+                  <a:pt x="14517" y="3969"/>
+                  <a:pt x="12419" y="1243"/>
+                  <a:pt x="11883" y="0"/>
+                </a:cubicBezTo>
+                <a:close/>
+              </a:path>
+            </a:pathLst>
+          </a:custGeom>
+          <a:solidFill>
+            <a:schemeClr val="accent1">
+              <a:alpha val="10000"/>
+            </a:schemeClr>
+          </a:solidFill>
+          <a:ln>
+            <a:noFill/>
+          </a:ln>
+        </p:spPr>
+      </p:sp>
+      <p:sp>
+        <p:nvSpPr>
+          <p:cNvPr id="13" name="Wave line 1"/>
+          <p:cNvSpPr/>
+          <p:nvPr userDrawn="1"/>
+        </p:nvSpPr>
+        <p:spPr>
+          <a:xfrm>
+            <a:off x="0" y="0"/>
+            <a:ext cx="12192000" cy="6858000"/>
+          </a:xfrm>
+          <a:custGeom>
+            <a:avLst/>
+            <a:gdLst/>
+            <a:ahLst/>
+            <a:cxnLst/>
+            <a:rect l="0" t="0" r="r" b="b"/>
+            <a:pathLst>
+              <a:path w="16000" h="9000" fill="none">
+                <a:moveTo>
+                  <a:pt x="10979" y="0"/>
+                </a:moveTo>
+                <a:cubicBezTo>
+                  <a:pt x="11339" y="1778"/>
+                  <a:pt x="12909" y="4468"/>
+                  <a:pt x="12909" y="6089"/>
+                </a:cubicBezTo>
+                <a:cubicBezTo>
+                  <a:pt x="12909" y="7867"/>
+                  <a:pt x="12410" y="8713"/>
+                  <a:pt x="12278" y="9000"/>
+                </a:cubicBezTo>
+              </a:path>
+            </a:pathLst>
+          </a:custGeom>
+          <a:noFill/>
+          <a:ln w="18288">
+            <a:solidFill>
+              <a:schemeClr val="accent1"/>
+            </a:solidFill>
+          </a:ln>
+        </p:spPr>
+      </p:sp>
+      <p:sp>
+        <p:nvSpPr>
+          <p:cNvPr id="14" name="Wave line 2"/>
+          <p:cNvSpPr/>
+          <p:nvPr userDrawn="1"/>
+        </p:nvSpPr>
+        <p:spPr>
+          <a:xfrm>
+            <a:off x="0" y="0"/>
+            <a:ext cx="12192000" cy="6858000"/>
+          </a:xfrm>
+          <a:custGeom>
+            <a:avLst/>
+            <a:gdLst/>
+            <a:ahLst/>
+            <a:cxnLst/>
+            <a:rect l="0" t="0" r="r" b="b"/>
+            <a:pathLst>
+              <a:path w="16000" h="9000" fill="none">
+                <a:moveTo>
+                  <a:pt x="11421" y="0"/>
+                </a:moveTo>
+                <a:cubicBezTo>
+                  <a:pt x="11843" y="1425"/>
+                  <a:pt x="13712" y="4272"/>
+                  <a:pt x="13712" y="5781"/>
+                </a:cubicBezTo>
+                <a:cubicBezTo>
+                  <a:pt x="13712" y="7476"/>
+                  <a:pt x="13258" y="8249"/>
+                  <a:pt x="12800" y="9000"/>
+                </a:cubicBezTo>
+              </a:path>
+            </a:pathLst>
+          </a:custGeom>
+          <a:noFill/>
+          <a:ln w="18288">
+            <a:solidFill>
+              <a:schemeClr val="accent1"/>
+            </a:solidFill>
+          </a:ln>
+        </p:spPr>
+      </p:sp>
+      <p:sp>
+        <p:nvSpPr>
+          <p:cNvPr id="15" name="Wave line 3"/>
+          <p:cNvSpPr/>
+          <p:nvPr userDrawn="1"/>
+        </p:nvSpPr>
+        <p:spPr>
+          <a:xfrm>
+            <a:off x="0" y="0"/>
+            <a:ext cx="12192000" cy="6858000"/>
+          </a:xfrm>
+          <a:custGeom>
+            <a:avLst/>
+            <a:gdLst/>
+            <a:ahLst/>
+            <a:cxnLst/>
+            <a:rect l="0" t="0" r="r" b="b"/>
+            <a:pathLst>
+              <a:path w="16000" h="9000" fill="none">
+                <a:moveTo>
+                  <a:pt x="11883" y="0"/>
+                </a:moveTo>
+                <a:cubicBezTo>
+                  <a:pt x="12419" y="1243"/>
+                  <a:pt x="14517" y="3969"/>
+                  <a:pt x="14517" y="5564"/>
+                </a:cubicBezTo>
+                <a:cubicBezTo>
+                  <a:pt x="14517" y="7418"/>
+                  <a:pt x="13822" y="8320"/>
+                  <a:pt x="13312" y="9000"/>
+                </a:cubicBezTo>
+              </a:path>
+            </a:pathLst>
+          </a:custGeom>
+          <a:noFill/>
+          <a:ln w="18288">
+            <a:solidFill>
+              <a:schemeClr val="accent1"/>
+            </a:solidFill>
+          </a:ln>
+        </p:spPr>
+      </p:sp>
+      <p:pic>
+        <p:nvPicPr>
+          <p:cNvPr id="16" name="Logo (dark)"/>
+          <p:cNvPicPr>
+            <a:picLocks noChangeAspect="1"/>
+          </p:cNvPicPr>
+          <p:nvPr userDrawn="1"/>
+        </p:nvPicPr>
+        <p:blipFill>
+          <a:blip r:embed="rId2"/>
+          <a:stretch>
+            <a:fillRect/>
+          </a:stretch>
+        </p:blipFill>
+        <p:spPr>
+          <a:xfrm>
+            <a:off x="731520" y="617220"/>
+            <a:ext cx="2697937" cy="685800"/>
+          </a:xfrm>
+          <a:prstGeom prst="rect">
+            <a:avLst/>
+          </a:prstGeom>
+        </p:spPr>
+      </p:pic>
+      <p:sp>
+        <p:nvSpPr>
+          <p:cNvPr id="17" name="Title tab"/>
+          <p:cNvSpPr/>
+          <p:nvPr userDrawn="1"/>
+        </p:nvSpPr>
+        <p:spPr>
+          <a:xfrm>
+            <a:off x="0" y="2537460"/>
+            <a:ext cx="219456" cy="514350"/>
+          </a:xfrm>
+          <a:prstGeom prst="rect">
+            <a:avLst/>
+          </a:prstGeom>
+          <a:solidFill>
+            <a:schemeClr val="accent4"/>
+          </a:solidFill>
+          <a:ln>
+            <a:noFill/>
+          </a:ln>
+        </p:spPr>
+      </p:sp>
+      <p:sp>
+        <p:nvSpPr>
+          <p:cNvPr id="18" name="Title 1"/>
+          <p:cNvSpPr>
+            <a:spLocks noGrp="1"/>
+          </p:cNvSpPr>
+          <p:nvPr>
+            <p:ph type="title"/>
+          </p:nvPr>
+        </p:nvSpPr>
+        <p:spPr>
+          <a:xfrm>
+            <a:off x="731520" y="2057400"/>
+            <a:ext cx="7559040" cy="1097280"/>
+          </a:xfrm>
+          <a:prstGeom prst="rect">
+            <a:avLst/>
+          </a:prstGeom>
+        </p:spPr>
+        <p:txBody>
+          <a:bodyPr vert="horz" lIns="0" tIns="0" rIns="0" bIns="0" anchor="b">
+            <a:normAutofit/>
+          </a:bodyPr>
+          <a:lstStyle>
+            <a:lvl1pPr algn="l">
+              <a:lnSpc>
+                <a:spcPct val="90000"/>
+              </a:lnSpc>
+              <a:defRPr sz="4400" b="1">
+                <a:solidFill>
+                  <a:srgbClr val="FFFFFF"/>
+                </a:solidFill>
+                <a:latin typeface="+mj-lt"/>
+              </a:defRPr>
+            </a:lvl1pPr>
+          </a:lstStyle>
+          <a:p>
+            <a:r>
+              <a:rPr lang="en-US"/>
+              <a:t>Thank you</a:t>
+            </a:r>
+          </a:p>
+        </p:txBody>
+      </p:sp>
+      <p:sp>
+        <p:nvSpPr>
+          <p:cNvPr id="19" name="Content Placeholder 2"/>
+          <p:cNvSpPr>
+            <a:spLocks noGrp="1"/>
+          </p:cNvSpPr>
+          <p:nvPr>
+            <p:ph idx="1"/>
+          </p:nvPr>
+        </p:nvSpPr>
+        <p:spPr>
+          <a:xfrm>
+            <a:off x="731520" y="3360420"/>
+            <a:ext cx="7071360" cy="2468880"/>
+          </a:xfrm>
+          <a:prstGeom prst="rect">
+            <a:avLst/>
+          </a:prstGeom>
+        </p:spPr>
+        <p:txBody>
+          <a:bodyPr vert="horz" lIns="0" tIns="0" rIns="0" bIns="0" anchor="t">
+            <a:normAutofit/>
+          </a:bodyPr>
+          <a:lstStyle>
+            <a:lvl1pPr>
+              <a:defRPr sz="2000">
+                <a:solidFill>
+                  <a:srgbClr val="FFFFFF"/>
+                </a:solidFill>
+              </a:defRPr>
+            </a:lvl1pPr>
+            <a:lvl2pPr>
+              <a:defRPr sz="1800">
+                <a:solidFill>
+                  <a:srgbClr val="FFFFFF"/>
+                </a:solidFill>
+              </a:defRPr>
+            </a:lvl2pPr>
+            <a:lvl3pPr>
+              <a:defRPr sz="1600">
+                <a:solidFill>
+                  <a:srgbClr val="FFFFFF"/>
+                </a:solidFill>
+              </a:defRPr>
+            </a:lvl3pPr>
+          </a:lstStyle>
+          <a:p>
+            <a:r>
+              <a:rPr lang="en-US"/>
+              <a:t>Contact details</a:t>
+            </a:r>
+          </a:p>
+        </p:txBody>
+      </p:sp>
+      <p:sp>
+        <p:nvSpPr>
+          <p:cNvPr id="20" name="Slide Number Placeholder"/>
+          <p:cNvSpPr>
+            <a:spLocks noGrp="1"/>
+          </p:cNvSpPr>
+          <p:nvPr>
+            <p:ph type="sldNum" sz="quarter" idx="22"/>
+          </p:nvPr>
+        </p:nvSpPr>
+        <p:spPr>
+          <a:xfrm>
+            <a:off x="12192" y="6480810"/>
+            <a:ext cx="475488" cy="363474"/>
+          </a:xfrm>
+        </p:spPr>
+        <p:txBody>
+          <a:bodyPr anchor="ctr"/>
+          <a:lstStyle>
+            <a:lvl1pPr algn="ctr">
+              <a:defRPr sz="1200" b="1">
+                <a:solidFill>
+                  <a:srgbClr val="FFFFFF"/>
+                </a:solidFill>
+              </a:defRPr>
+            </a:lvl1pPr>
+          </a:lstStyle>
+          <a:p>
+            <a:fld id="{C5EF2332-01BF-834F-8236-50238282D533}" type="slidenum">
+              <a:rPr lang="en-US"/>
+              <a:t>‹#›</a:t>
+            </a:fld>
+          </a:p>
+        </p:txBody>
+      </p:sp>
+      <p:sp>
+        <p:nvSpPr>
+          <p:cNvPr id="21" name="Date Placeholder"/>
+          <p:cNvSpPr>
+            <a:spLocks noGrp="1"/>
+          </p:cNvSpPr>
+          <p:nvPr>
+            <p:ph type="dt" sz="half" idx="20"/>
+          </p:nvPr>
+        </p:nvSpPr>
+        <p:spPr>
+          <a:xfrm>
+            <a:off x="10436352" y="6556248"/>
+            <a:ext cx="1377696" cy="185166"/>
+          </a:xfrm>
+          <a:prstGeom prst="rect">
+            <a:avLst/>
+          </a:prstGeom>
+        </p:spPr>
+        <p:txBody>
+          <a:bodyPr vert="horz" lIns="0" tIns="0" rIns="0" bIns="0" anchor="ctr"/>
+          <a:lstStyle>
+            <a:lvl1pPr algn="r">
+              <a:defRPr sz="900">
+                <a:solidFill>
+                  <a:srgbClr val="FFFFFF"/>
+                </a:solidFill>
+              </a:defRPr>
+            </a:lvl1pPr>
+          </a:lstStyle>
+          <a:p>
+            <a:r>
+              <a:rPr lang="en-US"/>
+              <a:t/>
+            </a:r>
+          </a:p>
+        </p:txBody>
+      </p:sp>
+      <p:sp>
+        <p:nvSpPr>
+          <p:cNvPr id="22" name="Footer Placeholder"/>
+          <p:cNvSpPr>
+            <a:spLocks noGrp="1"/>
+          </p:cNvSpPr>
+          <p:nvPr>
+            <p:ph type="ftr" sz="quarter" idx="21"/>
+          </p:nvPr>
+        </p:nvSpPr>
+        <p:spPr>
+          <a:xfrm>
+            <a:off x="560832" y="6556248"/>
+            <a:ext cx="4145280" cy="185166"/>
+          </a:xfrm>
+          <a:prstGeom prst="rect">
+            <a:avLst/>
+          </a:prstGeom>
+        </p:spPr>
+        <p:txBody>
+          <a:bodyPr vert="horz" lIns="0" tIns="0" rIns="0" bIns="0" anchor="ctr"/>
+          <a:lstStyle>
+            <a:lvl1pPr algn="l">
+              <a:defRPr sz="900">
+                <a:solidFill>
+                  <a:srgbClr val="FFFFFF"/>
+                </a:solidFill>
+              </a:defRPr>
+            </a:lvl1pPr>
+          </a:lstStyle>
+          <a:p>
+            <a:r>
+              <a:rPr lang="en-US"/>
+              <a:t/>
+            </a:r>
+          </a:p>
+        </p:txBody>
+      </p:sp>
+    </p:spTree>
+  </p:cSld>
+  <p:clrMapOvr>
+    <a:masterClrMapping/>
+  </p:clrMapOvr>
+</p:sldLayout>
+</file>
+
+<file path=ppt/slideLayouts/slideLayout9.xml><?xml version="1.0" encoding="utf-8"?>
+<p:sldLayout xmlns:a="http://schemas.openxmlformats.org/drawingml/2006/main" xmlns:r="http://schemas.openxmlformats.org/officeDocument/2006/relationships" xmlns:p="http://schemas.openxmlformats.org/presentationml/2006/main" type="title" preserve="1" showMasterSp="0">
+  <p:cSld name="Title Slide (light)">
+    <p:bg>
+      <p:bgPr>
+        <a:solidFill>
+          <a:schemeClr val="bg1"/>
+        </a:solidFill>
+        <a:effectLst/>
+      </p:bgPr>
+    </p:bg>
+    <p:spTree>
+      <p:nvGrpSpPr>
+        <p:cNvPr id="1" name=""/>
+        <p:cNvGrpSpPr/>
+        <p:nvPr/>
+      </p:nvGrpSpPr>
+      <p:grpSpPr>
+        <a:xfrm>
+          <a:off x="0" y="0"/>
+          <a:ext cx="0" cy="0"/>
+          <a:chOff x="0" y="0"/>
+          <a:chExt cx="0" cy="0"/>
+        </a:xfrm>
+      </p:grpSpPr>
+      <p:sp>
+        <p:nvSpPr>
+          <p:cNvPr id="11" name="Wave line 1"/>
+          <p:cNvSpPr/>
+          <p:nvPr userDrawn="1"/>
+        </p:nvSpPr>
+        <p:spPr>
+          <a:xfrm>
+            <a:off x="0" y="0"/>
+            <a:ext cx="12192000" cy="6858000"/>
+          </a:xfrm>
+          <a:custGeom>
+            <a:avLst/>
+            <a:gdLst/>
+            <a:ahLst/>
+            <a:cxnLst/>
+            <a:rect l="0" t="0" r="r" b="b"/>
+            <a:pathLst>
+              <a:path w="16000" h="9000" fill="none">
+                <a:moveTo>
+                  <a:pt x="10979" y="0"/>
+                </a:moveTo>
+                <a:cubicBezTo>
+                  <a:pt x="11339" y="1778"/>
+                  <a:pt x="12909" y="4468"/>
+                  <a:pt x="12909" y="6089"/>
+                </a:cubicBezTo>
+                <a:cubicBezTo>
+                  <a:pt x="12909" y="7867"/>
+                  <a:pt x="12410" y="8713"/>
+                  <a:pt x="12278" y="9000"/>
+                </a:cubicBezTo>
+              </a:path>
+            </a:pathLst>
+          </a:custGeom>
+          <a:noFill/>
+          <a:ln w="18288">
+            <a:solidFill>
+              <a:schemeClr val="accent1"/>
+            </a:solidFill>
+          </a:ln>
+        </p:spPr>
+      </p:sp>
+      <p:sp>
+        <p:nvSpPr>
+          <p:cNvPr id="12" name="Wave line 2"/>
+          <p:cNvSpPr/>
+          <p:nvPr userDrawn="1"/>
+        </p:nvSpPr>
+        <p:spPr>
+          <a:xfrm>
+            <a:off x="0" y="0"/>
+            <a:ext cx="12192000" cy="6858000"/>
+          </a:xfrm>
+          <a:custGeom>
+            <a:avLst/>
+            <a:gdLst/>
+            <a:ahLst/>
+            <a:cxnLst/>
+            <a:rect l="0" t="0" r="r" b="b"/>
+            <a:pathLst>
+              <a:path w="16000" h="9000" fill="none">
+                <a:moveTo>
+                  <a:pt x="11421" y="0"/>
+                </a:moveTo>
+                <a:cubicBezTo>
+                  <a:pt x="11843" y="1425"/>
+                  <a:pt x="13712" y="4272"/>
+                  <a:pt x="13712" y="5781"/>
+                </a:cubicBezTo>
+                <a:cubicBezTo>
+                  <a:pt x="13712" y="7476"/>
+                  <a:pt x="13258" y="8249"/>
+                  <a:pt x="12800" y="9000"/>
+                </a:cubicBezTo>
+              </a:path>
+            </a:pathLst>
+          </a:custGeom>
+          <a:noFill/>
+          <a:ln w="18288">
+            <a:solidFill>
+              <a:schemeClr val="accent1"/>
+            </a:solidFill>
+          </a:ln>
+        </p:spPr>
+      </p:sp>
+      <p:sp>
+        <p:nvSpPr>
+          <p:cNvPr id="13" name="Wave line 3"/>
+          <p:cNvSpPr/>
+          <p:nvPr userDrawn="1"/>
+        </p:nvSpPr>
+        <p:spPr>
+          <a:xfrm>
+            <a:off x="0" y="0"/>
+            <a:ext cx="12192000" cy="6858000"/>
+          </a:xfrm>
+          <a:custGeom>
+            <a:avLst/>
+            <a:gdLst/>
+            <a:ahLst/>
+            <a:cxnLst/>
+            <a:rect l="0" t="0" r="r" b="b"/>
+            <a:pathLst>
+              <a:path w="16000" h="9000" fill="none">
+                <a:moveTo>
+                  <a:pt x="11883" y="0"/>
+                </a:moveTo>
+                <a:cubicBezTo>
+                  <a:pt x="12419" y="1243"/>
+                  <a:pt x="14517" y="3969"/>
+                  <a:pt x="14517" y="5564"/>
+                </a:cubicBezTo>
+                <a:cubicBezTo>
+                  <a:pt x="14517" y="7418"/>
+                  <a:pt x="13822" y="8320"/>
+                  <a:pt x="13312" y="9000"/>
+                </a:cubicBezTo>
+              </a:path>
+            </a:pathLst>
+          </a:custGeom>
+          <a:noFill/>
+          <a:ln w="18288">
+            <a:solidFill>
+              <a:schemeClr val="accent1"/>
+            </a:solidFill>
+          </a:ln>
+        </p:spPr>
+      </p:sp>
+      <p:pic>
+        <p:nvPicPr>
+          <p:cNvPr id="14" name="Logo (light)"/>
+          <p:cNvPicPr>
+            <a:picLocks noChangeAspect="1"/>
+          </p:cNvPicPr>
+          <p:nvPr userDrawn="1"/>
+        </p:nvPicPr>
+        <p:blipFill>
+          <a:blip r:embed="rId2"/>
+          <a:stretch>
+            <a:fillRect/>
+          </a:stretch>
+        </p:blipFill>
+        <p:spPr>
+          <a:xfrm>
+            <a:off x="731520" y="411480"/>
+            <a:ext cx="2428143" cy="617220"/>
+          </a:xfrm>
+          <a:prstGeom prst="rect">
+            <a:avLst/>
+          </a:prstGeom>
+        </p:spPr>
+      </p:pic>
+      <p:sp>
+        <p:nvSpPr>
+          <p:cNvPr id="15" name="Title tab"/>
+          <p:cNvSpPr/>
+          <p:nvPr userDrawn="1"/>
+        </p:nvSpPr>
+        <p:spPr>
+          <a:xfrm>
+            <a:off x="0" y="2948940"/>
+            <a:ext cx="219456" cy="1097280"/>
+          </a:xfrm>
+          <a:prstGeom prst="rect">
+            <a:avLst/>
+          </a:prstGeom>
+          <a:solidFill>
+            <a:schemeClr val="accent4"/>
+          </a:solidFill>
+          <a:ln>
+            <a:noFill/>
+          </a:ln>
+        </p:spPr>
+      </p:sp>
+      <p:sp>
+        <p:nvSpPr>
+          <p:cNvPr id="16" name="Date"/>
+          <p:cNvSpPr>
+            <a:spLocks noGrp="1"/>
+          </p:cNvSpPr>
+          <p:nvPr>
+            <p:ph type="dt" idx="20"/>
+          </p:nvPr>
+        </p:nvSpPr>
+        <p:spPr>
+          <a:xfrm>
+            <a:off x="731520" y="2571750"/>
+            <a:ext cx="5486400" cy="308610"/>
+          </a:xfrm>
+          <a:prstGeom prst="rect">
+            <a:avLst/>
+          </a:prstGeom>
+        </p:spPr>
+        <p:txBody>
+          <a:bodyPr vert="horz" lIns="0" tIns="0" rIns="0" bIns="0" anchor="t">
+            <a:normAutofit/>
+          </a:bodyPr>
+          <a:lstStyle>
+            <a:lvl1pPr algn="l" marL="0" indent="0">
+              <a:spcBef>
+                <a:spcPts val="0"/>
+              </a:spcBef>
+              <a:buNone/>
+              <a:defRPr sz="1200" b="1" cap="all">
+                <a:solidFill>
+                  <a:srgbClr val="00357A"/>
+                </a:solidFill>
+                <a:latin typeface="+mn-lt"/>
+              </a:defRPr>
+            </a:lvl1pPr>
+          </a:lstStyle>
+          <a:p>
+            <a:fld id="{B6F15528-21DE-4FAA-801E-634DDDAF4B2B}" type="datetime1">
+              <a:rPr lang="en-US"/>
+              <a:t>Date</a:t>
+            </a:fld>
+          </a:p>
+        </p:txBody>
+      </p:sp>
+      <p:sp>
+        <p:nvSpPr>
+          <p:cNvPr id="17" name="Title"/>
+          <p:cNvSpPr>
+            <a:spLocks noGrp="1"/>
+          </p:cNvSpPr>
+          <p:nvPr>
+            <p:ph type="ctrTitle"/>
+          </p:nvPr>
+        </p:nvSpPr>
+        <p:spPr>
+          <a:xfrm>
+            <a:off x="731520" y="2948940"/>
+            <a:ext cx="6096000" cy="1097280"/>
+          </a:xfrm>
+          <a:prstGeom prst="rect">
+            <a:avLst/>
+          </a:prstGeom>
+        </p:spPr>
+        <p:txBody>
+          <a:bodyPr vert="horz" lIns="0" tIns="0" rIns="0" bIns="0" anchor="t">
+            <a:normAutofit/>
+          </a:bodyPr>
+          <a:lstStyle>
+            <a:lvl1pPr algn="l" marL="0" indent="0">
+              <a:spcBef>
+                <a:spcPts val="0"/>
+              </a:spcBef>
+              <a:buNone/>
+              <a:defRPr sz="3600" b="1">
+                <a:solidFill>
+                  <a:srgbClr val="00357A"/>
+                </a:solidFill>
+                <a:latin typeface="+mn-lt"/>
+              </a:defRPr>
+            </a:lvl1pPr>
+          </a:lstStyle>
+          <a:p>
+            <a:r>
+              <a:rPr lang="en-US"/>
+              <a:t>Title</a:t>
+            </a:r>
+          </a:p>
+        </p:txBody>
+      </p:sp>
+      <p:cxnSp>
+        <p:nvCxnSpPr>
+          <p:cNvPr id="18" name="Title rule"/>
+          <p:cNvCxnSpPr/>
+          <p:nvPr userDrawn="1"/>
+        </p:nvCxnSpPr>
+        <p:spPr>
+          <a:xfrm>
+            <a:off x="731520" y="4217670"/>
+            <a:ext cx="792480" cy="0"/>
+          </a:xfrm>
+          <a:prstGeom prst="line">
+            <a:avLst/>
+          </a:prstGeom>
+          <a:ln w="19050">
+            <a:solidFill>
+              <a:schemeClr val="accent1"/>
+            </a:solidFill>
+          </a:ln>
+        </p:spPr>
+      </p:cxnSp>
+      <p:sp>
+        <p:nvSpPr>
+          <p:cNvPr id="19" name="Subtitle"/>
+          <p:cNvSpPr>
+            <a:spLocks noGrp="1"/>
+          </p:cNvSpPr>
+          <p:nvPr>
+            <p:ph type="subTitle" idx="1"/>
+          </p:nvPr>
+        </p:nvSpPr>
+        <p:spPr>
+          <a:xfrm>
+            <a:off x="731520" y="4389120"/>
+            <a:ext cx="6096000" cy="1508760"/>
+          </a:xfrm>
+          <a:prstGeom prst="rect">
+            <a:avLst/>
+          </a:prstGeom>
+        </p:spPr>
+        <p:txBody>
+          <a:bodyPr vert="horz" lIns="0" tIns="0" rIns="0" bIns="0" anchor="t">
+            <a:normAutofit/>
+          </a:bodyPr>
+          <a:lstStyle>
+            <a:lvl1pPr algn="l" marL="0" indent="0">
+              <a:spcBef>
+                <a:spcPts val="0"/>
+              </a:spcBef>
+              <a:buNone/>
+              <a:defRPr sz="1800" b="0">
+                <a:solidFill>
+                  <a:srgbClr val="00357A"/>
+                </a:solidFill>
+                <a:latin typeface="+mn-lt"/>
+              </a:defRPr>
+            </a:lvl1pPr>
+          </a:lstStyle>
+          <a:p>
+            <a:r>
+              <a:rPr lang="en-US"/>
+              <a:t>Subtitle</a:t>
+            </a:r>
+          </a:p>
+        </p:txBody>
+      </p:sp>
+      <p:sp>
+        <p:nvSpPr>
+          <p:cNvPr id="20" name="Slide Number Placeholder"/>
+          <p:cNvSpPr>
+            <a:spLocks noGrp="1"/>
+          </p:cNvSpPr>
+          <p:nvPr>
+            <p:ph type="sldNum" sz="quarter" idx="22"/>
+          </p:nvPr>
+        </p:nvSpPr>
+        <p:spPr>
+          <a:xfrm>
+            <a:off x="12192" y="6480810"/>
+            <a:ext cx="475488" cy="363474"/>
+          </a:xfrm>
+        </p:spPr>
+        <p:txBody>
+          <a:bodyPr anchor="ctr"/>
+          <a:lstStyle>
+            <a:lvl1pPr algn="ctr">
+              <a:defRPr sz="1200" b="1">
+                <a:solidFill>
+                  <a:srgbClr val="00357A"/>
+                </a:solidFill>
+              </a:defRPr>
+            </a:lvl1pPr>
+          </a:lstStyle>
+          <a:p>
+            <a:fld id="{C5EF2332-01BF-834F-8236-50238282D533}" type="slidenum">
+              <a:rPr lang="en-US"/>
+              <a:t>‹#›</a:t>
+            </a:fld>
+          </a:p>
+        </p:txBody>
+      </p:sp>
+      <p:sp>
+        <p:nvSpPr>
+          <p:cNvPr id="22" name="Footer Placeholder"/>
+          <p:cNvSpPr>
+            <a:spLocks noGrp="1"/>
+          </p:cNvSpPr>
+          <p:nvPr>
+            <p:ph type="ftr" sz="quarter" idx="21"/>
+          </p:nvPr>
+        </p:nvSpPr>
+        <p:spPr>
+          <a:xfrm>
+            <a:off x="560832" y="6556248"/>
+            <a:ext cx="4145280" cy="185166"/>
+          </a:xfrm>
+          <a:prstGeom prst="rect">
+            <a:avLst/>
+          </a:prstGeom>
+        </p:spPr>
+        <p:txBody>
+          <a:bodyPr vert="horz" lIns="0" tIns="0" rIns="0" bIns="0" anchor="ctr"/>
+          <a:lstStyle>
+            <a:lvl1pPr algn="l">
+              <a:defRPr sz="900">
+                <a:solidFill>
+                  <a:srgbClr val="00357A"/>
+                </a:solidFill>
+              </a:defRPr>
+            </a:lvl1pPr>
+          </a:lstStyle>
+          <a:p>
+            <a:r>
+              <a:rPr lang="en-US"/>
+              <a:t/>
+            </a:r>
+          </a:p>
+        </p:txBody>
+      </p:sp>
+    </p:spTree>
+  </p:cSld>
+  <p:clrMapOvr>
+    <a:masterClrMapping/>
+  </p:clrMapOvr>
+</p:sldLayout>
+</file>
+
 <file path=ppt/slideMasters/slideMaster1.xml><?xml version="1.0" encoding="utf-8"?>
 <p:sldMaster xmlns:a="http://schemas.openxmlformats.org/drawingml/2006/main" xmlns:r="http://schemas.openxmlformats.org/officeDocument/2006/relationships" xmlns:p="http://schemas.openxmlformats.org/presentationml/2006/main">
   <p:cSld>
@@ -2574,6 +3546,8 @@
     <p:sldLayoutId id="2147483653" r:id="rId14"/>
     <p:sldLayoutId id="2147483654" r:id="rId15"/>
     <p:sldLayoutId id="2147483655" r:id="rId16"/>
+    <p:sldLayoutId id="2147483656" r:id="rId17"/>
+    <p:sldLayoutId id="2147483657" r:id="rId18"/>
   </p:sldLayoutIdLst>
   <p:txStyles>
     <p:titleStyle>

</xml_diff>

<commit_message>
ncar: the cover title's text from the pptx template's date line (0.375), the sprint's last step
Ben, 2026-10-17: the NCAR pptx's lower title stack is the look to mimic, done as the
composition sprint's final commit (it was #22, reverted in #23 until every format drew from
the boxes). ncar's livery.yml overrides compositions.title.column to [0.06, 0.375, 0.50,
0.485], anchored at the top, ending at the fineprint; it reaches the photo (0.44 wide) and
light variants and the ucar, ucp and ncarucar flavors, in all three formats at once (the
templates regenerated: the title placeholders return to the brand template's 0.375 stack).
cu, nsi and new liveries keep the engine default under the mark.

Co-Authored-By: Claude Opus 5.5 <noreply@anthropic.com>
Claude-Session: https://claude.ai/code/session_01QxTZPtUJESWqMyXE15JCRv
</commit_message>
<xml_diff>
--- a/_extensions/engine/liveries/ncar/template.pptx
+++ b/_extensions/engine/liveries/ncar/template.pptx
@@ -319,7 +319,7 @@
         </p:nvSpPr>
         <p:spPr>
           <a:xfrm>
-            <a:off x="0" y="1748790"/>
+            <a:off x="0" y="2948940"/>
             <a:ext cx="219456" cy="1097280"/>
           </a:xfrm>
           <a:prstGeom prst="rect">
@@ -345,7 +345,7 @@
         </p:nvSpPr>
         <p:spPr>
           <a:xfrm>
-            <a:off x="731520" y="1371600"/>
+            <a:off x="731520" y="2571750"/>
             <a:ext cx="6096000" cy="308610"/>
           </a:xfrm>
           <a:prstGeom prst="rect">
@@ -390,7 +390,7 @@
         </p:nvSpPr>
         <p:spPr>
           <a:xfrm>
-            <a:off x="731520" y="1748790"/>
+            <a:off x="731520" y="2948940"/>
             <a:ext cx="6096000" cy="1097280"/>
           </a:xfrm>
           <a:prstGeom prst="rect">
@@ -431,7 +431,7 @@
         </p:nvCxnSpPr>
         <p:spPr>
           <a:xfrm>
-            <a:off x="731520" y="3017520"/>
+            <a:off x="731520" y="4217670"/>
             <a:ext cx="1584960" cy="0"/>
           </a:xfrm>
           <a:prstGeom prst="line">
@@ -456,8 +456,8 @@
         </p:nvSpPr>
         <p:spPr>
           <a:xfrm>
-            <a:off x="731520" y="3188970"/>
-            <a:ext cx="6096000" cy="2708910"/>
+            <a:off x="731520" y="4389120"/>
+            <a:ext cx="6096000" cy="1508760"/>
           </a:xfrm>
           <a:prstGeom prst="rect">
             <a:avLst/>
@@ -3305,7 +3305,7 @@
         </p:nvSpPr>
         <p:spPr>
           <a:xfrm>
-            <a:off x="0" y="1748790"/>
+            <a:off x="0" y="2948940"/>
             <a:ext cx="219456" cy="1097280"/>
           </a:xfrm>
           <a:prstGeom prst="rect">
@@ -3331,7 +3331,7 @@
         </p:nvSpPr>
         <p:spPr>
           <a:xfrm>
-            <a:off x="731520" y="1371600"/>
+            <a:off x="731520" y="2571750"/>
             <a:ext cx="6096000" cy="308610"/>
           </a:xfrm>
           <a:prstGeom prst="rect">
@@ -3376,7 +3376,7 @@
         </p:nvSpPr>
         <p:spPr>
           <a:xfrm>
-            <a:off x="731520" y="1748790"/>
+            <a:off x="731520" y="2948940"/>
             <a:ext cx="6096000" cy="1097280"/>
           </a:xfrm>
           <a:prstGeom prst="rect">
@@ -3417,7 +3417,7 @@
         </p:nvCxnSpPr>
         <p:spPr>
           <a:xfrm>
-            <a:off x="731520" y="3017520"/>
+            <a:off x="731520" y="4217670"/>
             <a:ext cx="1584960" cy="0"/>
           </a:xfrm>
           <a:prstGeom prst="line">
@@ -3442,8 +3442,8 @@
         </p:nvSpPr>
         <p:spPr>
           <a:xfrm>
-            <a:off x="731520" y="3188970"/>
-            <a:ext cx="6096000" cy="2708910"/>
+            <a:off x="731520" y="4389120"/>
+            <a:ext cx="6096000" cy="1508760"/>
           </a:xfrm>
           <a:prstGeom prst="rect">
             <a:avLst/>

</xml_diff>

<commit_message>
ncar: the cover title's text from the pptx template's date line (0.375), the sprint's last step (#29)
Ben, 2026-10-17: the NCAR pptx's lower title stack is the look to mimic, done as the
composition sprint's final commit (it was #22, reverted in #23 until every format drew from
the boxes). ncar's livery.yml overrides compositions.title.column to [0.06, 0.375, 0.50,
0.485], anchored at the top, ending at the fineprint; it reaches the photo (0.44 wide) and
light variants and the ucar, ucp and ncarucar flavors, in all three formats at once (the
templates regenerated: the title placeholders return to the brand template's 0.375 stack).
cu, nsi and new liveries keep the engine default under the mark.


Claude-Session: https://claude.ai/code/session_01QxTZPtUJESWqMyXE15JCRv

Co-authored-by: Claude Opus 5.5 <noreply@anthropic.com>
</commit_message>
<xml_diff>
--- a/_extensions/engine/liveries/ncar/template.pptx
+++ b/_extensions/engine/liveries/ncar/template.pptx
@@ -319,7 +319,7 @@
         </p:nvSpPr>
         <p:spPr>
           <a:xfrm>
-            <a:off x="0" y="1748790"/>
+            <a:off x="0" y="2948940"/>
             <a:ext cx="219456" cy="1097280"/>
           </a:xfrm>
           <a:prstGeom prst="rect">
@@ -345,7 +345,7 @@
         </p:nvSpPr>
         <p:spPr>
           <a:xfrm>
-            <a:off x="731520" y="1371600"/>
+            <a:off x="731520" y="2571750"/>
             <a:ext cx="6096000" cy="308610"/>
           </a:xfrm>
           <a:prstGeom prst="rect">
@@ -390,7 +390,7 @@
         </p:nvSpPr>
         <p:spPr>
           <a:xfrm>
-            <a:off x="731520" y="1748790"/>
+            <a:off x="731520" y="2948940"/>
             <a:ext cx="6096000" cy="1097280"/>
           </a:xfrm>
           <a:prstGeom prst="rect">
@@ -431,7 +431,7 @@
         </p:nvCxnSpPr>
         <p:spPr>
           <a:xfrm>
-            <a:off x="731520" y="3017520"/>
+            <a:off x="731520" y="4217670"/>
             <a:ext cx="1584960" cy="0"/>
           </a:xfrm>
           <a:prstGeom prst="line">
@@ -456,8 +456,8 @@
         </p:nvSpPr>
         <p:spPr>
           <a:xfrm>
-            <a:off x="731520" y="3188970"/>
-            <a:ext cx="6096000" cy="2708910"/>
+            <a:off x="731520" y="4389120"/>
+            <a:ext cx="6096000" cy="1508760"/>
           </a:xfrm>
           <a:prstGeom prst="rect">
             <a:avLst/>
@@ -3305,7 +3305,7 @@
         </p:nvSpPr>
         <p:spPr>
           <a:xfrm>
-            <a:off x="0" y="1748790"/>
+            <a:off x="0" y="2948940"/>
             <a:ext cx="219456" cy="1097280"/>
           </a:xfrm>
           <a:prstGeom prst="rect">
@@ -3331,7 +3331,7 @@
         </p:nvSpPr>
         <p:spPr>
           <a:xfrm>
-            <a:off x="731520" y="1371600"/>
+            <a:off x="731520" y="2571750"/>
             <a:ext cx="6096000" cy="308610"/>
           </a:xfrm>
           <a:prstGeom prst="rect">
@@ -3376,7 +3376,7 @@
         </p:nvSpPr>
         <p:spPr>
           <a:xfrm>
-            <a:off x="731520" y="1748790"/>
+            <a:off x="731520" y="2948940"/>
             <a:ext cx="6096000" cy="1097280"/>
           </a:xfrm>
           <a:prstGeom prst="rect">
@@ -3417,7 +3417,7 @@
         </p:nvCxnSpPr>
         <p:spPr>
           <a:xfrm>
-            <a:off x="731520" y="3017520"/>
+            <a:off x="731520" y="4217670"/>
             <a:ext cx="1584960" cy="0"/>
           </a:xfrm>
           <a:prstGeom prst="line">
@@ -3442,8 +3442,8 @@
         </p:nvSpPr>
         <p:spPr>
           <a:xfrm>
-            <a:off x="731520" y="3188970"/>
-            <a:ext cx="6096000" cy="2708910"/>
+            <a:off x="731520" y="4389120"/>
+            <a:ext cx="6096000" cy="1508760"/>
           </a:xfrm>
           <a:prstGeom prst="rect">
             <a:avLst/>

</xml_diff>

<commit_message>
ncar on the NSF NCAR template's canvas and sizes (10 x 5.625 in; body 12, titles 20)
pptx.size [10, 5.625], the canvas of the brand's own templates (NSF NCAR, UCAR, UCP and
NCAR-UCAR, all 9144000 x 5143500 EMU), so a slide pastes into them 1:1; type: their
guidance in points (body 12, levels 12/11/10/9/8, page titles 20, subhead 15, tables 10,
cover title 22 over date 8 and presenter 12, bold statement 30, footer 7, notes 5).
ucar, ucp and ncarucar inherit both.

Co-Authored-By: Claude Opus 5.5 <noreply@anthropic.com>
Claude-Session: https://claude.ai/code/session_01QxTZPtUJESWqMyXE15JCRv
</commit_message>
<xml_diff>
--- a/_extensions/engine/liveries/ncar/template.pptx
+++ b/_extensions/engine/liveries/ncar/template.pptx
@@ -5,7 +5,7 @@
     <p:sldMasterId id="2147483648" r:id="rId1"/>
   </p:sldMasterIdLst>
   <p:sldIdLst/>
-  <p:sldSz cx="12192000" cy="6858000"/>
+  <p:sldSz cx="9144000" cy="5143500" type="screen16x9"/>
   <p:notesSz cx="6858000" cy="9144000"/>
   <p:defaultTextStyle>
     <a:defPPr>
@@ -49,7 +49,7 @@
         <p:spPr>
           <a:xfrm>
             <a:off x="0" y="0"/>
-            <a:ext cx="12192000" cy="6858000"/>
+            <a:ext cx="9144000" cy="5143500"/>
           </a:xfrm>
           <a:custGeom>
             <a:avLst/>
@@ -108,7 +108,7 @@
         <p:spPr>
           <a:xfrm>
             <a:off x="0" y="0"/>
-            <a:ext cx="12192000" cy="6858000"/>
+            <a:ext cx="9144000" cy="5143500"/>
           </a:xfrm>
           <a:custGeom>
             <a:avLst/>
@@ -167,7 +167,7 @@
         <p:spPr>
           <a:xfrm>
             <a:off x="0" y="0"/>
-            <a:ext cx="12192000" cy="6858000"/>
+            <a:ext cx="9144000" cy="5143500"/>
           </a:xfrm>
           <a:custGeom>
             <a:avLst/>
@@ -194,7 +194,7 @@
             </a:pathLst>
           </a:custGeom>
           <a:noFill/>
-          <a:ln w="18288">
+          <a:ln w="13716">
             <a:solidFill>
               <a:schemeClr val="accent1"/>
             </a:solidFill>
@@ -210,7 +210,7 @@
         <p:spPr>
           <a:xfrm>
             <a:off x="0" y="0"/>
-            <a:ext cx="12192000" cy="6858000"/>
+            <a:ext cx="9144000" cy="5143500"/>
           </a:xfrm>
           <a:custGeom>
             <a:avLst/>
@@ -237,7 +237,7 @@
             </a:pathLst>
           </a:custGeom>
           <a:noFill/>
-          <a:ln w="18288">
+          <a:ln w="13716">
             <a:solidFill>
               <a:schemeClr val="accent1"/>
             </a:solidFill>
@@ -253,7 +253,7 @@
         <p:spPr>
           <a:xfrm>
             <a:off x="0" y="0"/>
-            <a:ext cx="12192000" cy="6858000"/>
+            <a:ext cx="9144000" cy="5143500"/>
           </a:xfrm>
           <a:custGeom>
             <a:avLst/>
@@ -280,7 +280,7 @@
             </a:pathLst>
           </a:custGeom>
           <a:noFill/>
-          <a:ln w="18288">
+          <a:ln w="13716">
             <a:solidFill>
               <a:schemeClr val="accent1"/>
             </a:solidFill>
@@ -303,8 +303,8 @@
         </p:blipFill>
         <p:spPr>
           <a:xfrm>
-            <a:off x="731520" y="411480"/>
-            <a:ext cx="2428646" cy="617220"/>
+            <a:off x="548640" y="308610"/>
+            <a:ext cx="1821485" cy="462915"/>
           </a:xfrm>
           <a:prstGeom prst="rect">
             <a:avLst/>
@@ -319,8 +319,8 @@
         </p:nvSpPr>
         <p:spPr>
           <a:xfrm>
-            <a:off x="0" y="2948940"/>
-            <a:ext cx="219456" cy="1097280"/>
+            <a:off x="0" y="2211705"/>
+            <a:ext cx="164592" cy="822960"/>
           </a:xfrm>
           <a:prstGeom prst="rect">
             <a:avLst/>
@@ -345,8 +345,8 @@
         </p:nvSpPr>
         <p:spPr>
           <a:xfrm>
-            <a:off x="731520" y="2571750"/>
-            <a:ext cx="6096000" cy="308610"/>
+            <a:off x="548640" y="1928812"/>
+            <a:ext cx="4572000" cy="231458"/>
           </a:xfrm>
           <a:prstGeom prst="rect">
             <a:avLst/>
@@ -362,7 +362,7 @@
                 <a:spcPts val="0"/>
               </a:spcBef>
               <a:buNone/>
-              <a:defRPr sz="1100" b="1" cap="all">
+              <a:defRPr sz="800" b="1" cap="all">
                 <a:solidFill>
                   <a:srgbClr val="FFFFFF"/>
                 </a:solidFill>
@@ -390,8 +390,8 @@
         </p:nvSpPr>
         <p:spPr>
           <a:xfrm>
-            <a:off x="731520" y="2948940"/>
-            <a:ext cx="6096000" cy="1097280"/>
+            <a:off x="548640" y="2211705"/>
+            <a:ext cx="4572000" cy="822960"/>
           </a:xfrm>
           <a:prstGeom prst="rect">
             <a:avLst/>
@@ -407,7 +407,7 @@
                 <a:spcPts val="0"/>
               </a:spcBef>
               <a:buNone/>
-              <a:defRPr sz="2900" b="1">
+              <a:defRPr sz="2200" b="1">
                 <a:solidFill>
                   <a:srgbClr val="FFFFFF"/>
                 </a:solidFill>
@@ -431,13 +431,13 @@
         </p:nvCxnSpPr>
         <p:spPr>
           <a:xfrm>
-            <a:off x="731520" y="4217670"/>
-            <a:ext cx="1584960" cy="0"/>
+            <a:off x="548640" y="3163252"/>
+            <a:ext cx="1188720" cy="0"/>
           </a:xfrm>
           <a:prstGeom prst="line">
             <a:avLst/>
           </a:prstGeom>
-          <a:ln w="22631">
+          <a:ln w="16974">
             <a:solidFill>
               <a:schemeClr val="accent1"/>
             </a:solidFill>
@@ -456,8 +456,8 @@
         </p:nvSpPr>
         <p:spPr>
           <a:xfrm>
-            <a:off x="731520" y="4389120"/>
-            <a:ext cx="6096000" cy="1508760"/>
+            <a:off x="548640" y="3291840"/>
+            <a:ext cx="4572000" cy="1131570"/>
           </a:xfrm>
           <a:prstGeom prst="rect">
             <a:avLst/>
@@ -473,7 +473,7 @@
                 <a:spcPts val="0"/>
               </a:spcBef>
               <a:buNone/>
-              <a:defRPr sz="2000" b="0">
+              <a:defRPr sz="1500" b="0">
                 <a:solidFill>
                   <a:srgbClr val="FFFFFF"/>
                 </a:solidFill>
@@ -501,15 +501,15 @@
         </p:nvSpPr>
         <p:spPr>
           <a:xfrm>
-            <a:off x="12192" y="6480810"/>
-            <a:ext cx="475488" cy="363474"/>
+            <a:off x="9144" y="4860608"/>
+            <a:ext cx="356616" cy="272606"/>
           </a:xfrm>
         </p:spPr>
         <p:txBody>
           <a:bodyPr anchor="ctr"/>
           <a:lstStyle>
             <a:lvl1pPr algn="ctr">
-              <a:defRPr sz="900" b="1">
+              <a:defRPr sz="700" b="1">
                 <a:solidFill>
                   <a:srgbClr val="FFFFFF"/>
                 </a:solidFill>
@@ -536,8 +536,8 @@
         </p:nvSpPr>
         <p:spPr>
           <a:xfrm>
-            <a:off x="560832" y="6556248"/>
-            <a:ext cx="4145280" cy="185166"/>
+            <a:off x="420624" y="4917186"/>
+            <a:ext cx="3108960" cy="138874"/>
           </a:xfrm>
           <a:prstGeom prst="rect">
             <a:avLst/>
@@ -547,7 +547,7 @@
           <a:bodyPr vert="horz" lIns="0" tIns="0" rIns="0" bIns="0" anchor="ctr"/>
           <a:lstStyle>
             <a:lvl1pPr algn="l">
-              <a:defRPr sz="900">
+              <a:defRPr sz="700">
                 <a:solidFill>
                   <a:srgbClr val="FFFFFF"/>
                 </a:solidFill>
@@ -604,7 +604,7 @@
         <p:spPr>
           <a:xfrm>
             <a:off x="0" y="0"/>
-            <a:ext cx="12192000" cy="6858000"/>
+            <a:ext cx="9144000" cy="5143500"/>
           </a:xfrm>
           <a:custGeom>
             <a:avLst/>
@@ -631,7 +631,7 @@
             </a:pathLst>
           </a:custGeom>
           <a:noFill/>
-          <a:ln w="18288">
+          <a:ln w="13716">
             <a:solidFill>
               <a:schemeClr val="accent1"/>
             </a:solidFill>
@@ -647,7 +647,7 @@
         <p:spPr>
           <a:xfrm>
             <a:off x="0" y="0"/>
-            <a:ext cx="12192000" cy="6858000"/>
+            <a:ext cx="9144000" cy="5143500"/>
           </a:xfrm>
           <a:custGeom>
             <a:avLst/>
@@ -674,7 +674,7 @@
             </a:pathLst>
           </a:custGeom>
           <a:noFill/>
-          <a:ln w="18288">
+          <a:ln w="13716">
             <a:solidFill>
               <a:schemeClr val="accent1"/>
             </a:solidFill>
@@ -690,7 +690,7 @@
         <p:spPr>
           <a:xfrm>
             <a:off x="0" y="0"/>
-            <a:ext cx="12192000" cy="6858000"/>
+            <a:ext cx="9144000" cy="5143500"/>
           </a:xfrm>
           <a:custGeom>
             <a:avLst/>
@@ -717,7 +717,7 @@
             </a:pathLst>
           </a:custGeom>
           <a:noFill/>
-          <a:ln w="18288">
+          <a:ln w="13716">
             <a:solidFill>
               <a:schemeClr val="accent1"/>
             </a:solidFill>
@@ -740,8 +740,8 @@
         </p:blipFill>
         <p:spPr>
           <a:xfrm>
-            <a:off x="731520" y="617220"/>
-            <a:ext cx="2698090" cy="685800"/>
+            <a:off x="548640" y="462915"/>
+            <a:ext cx="2023567" cy="514350"/>
           </a:xfrm>
           <a:prstGeom prst="rect">
             <a:avLst/>
@@ -756,8 +756,8 @@
         </p:nvSpPr>
         <p:spPr>
           <a:xfrm>
-            <a:off x="0" y="3154680"/>
-            <a:ext cx="219456" cy="514350"/>
+            <a:off x="0" y="2366010"/>
+            <a:ext cx="164592" cy="385762"/>
           </a:xfrm>
           <a:prstGeom prst="rect">
             <a:avLst/>
@@ -782,8 +782,8 @@
         </p:nvSpPr>
         <p:spPr>
           <a:xfrm>
-            <a:off x="731520" y="1508760"/>
-            <a:ext cx="7559040" cy="2263140"/>
+            <a:off x="548640" y="1131570"/>
+            <a:ext cx="5669280" cy="1697355"/>
           </a:xfrm>
           <a:prstGeom prst="rect">
             <a:avLst/>
@@ -798,7 +798,7 @@
               <a:lnSpc>
                 <a:spcPct val="90000"/>
               </a:lnSpc>
-              <a:defRPr sz="4000" b="1">
+              <a:defRPr sz="3000" b="1">
                 <a:solidFill>
                   <a:srgbClr val="00357A"/>
                 </a:solidFill>
@@ -826,8 +826,8 @@
         </p:nvSpPr>
         <p:spPr>
           <a:xfrm>
-            <a:off x="731520" y="3977640"/>
-            <a:ext cx="7559040" cy="2057400"/>
+            <a:off x="548640" y="2983230"/>
+            <a:ext cx="5669280" cy="1543050"/>
           </a:xfrm>
           <a:prstGeom prst="rect">
             <a:avLst/>
@@ -839,21 +839,21 @@
           </a:bodyPr>
           <a:lstStyle>
             <a:lvl1pPr>
-              <a:defRPr sz="1600">
+              <a:defRPr sz="1200">
                 <a:solidFill>
                   <a:srgbClr val="00357A"/>
                 </a:solidFill>
               </a:defRPr>
             </a:lvl1pPr>
             <a:lvl2pPr>
-              <a:defRPr sz="1500">
+              <a:defRPr sz="1100">
                 <a:solidFill>
                   <a:srgbClr val="00357A"/>
                 </a:solidFill>
               </a:defRPr>
             </a:lvl2pPr>
             <a:lvl3pPr>
-              <a:defRPr sz="1300">
+              <a:defRPr sz="1000">
                 <a:solidFill>
                   <a:srgbClr val="00357A"/>
                 </a:solidFill>
@@ -880,15 +880,15 @@
         </p:nvSpPr>
         <p:spPr>
           <a:xfrm>
-            <a:off x="12192" y="6480810"/>
-            <a:ext cx="475488" cy="363474"/>
+            <a:off x="9144" y="4860608"/>
+            <a:ext cx="356616" cy="272606"/>
           </a:xfrm>
         </p:spPr>
         <p:txBody>
           <a:bodyPr anchor="ctr"/>
           <a:lstStyle>
             <a:lvl1pPr algn="ctr">
-              <a:defRPr sz="900" b="1">
+              <a:defRPr sz="700" b="1">
                 <a:solidFill>
                   <a:srgbClr val="00357A"/>
                 </a:solidFill>
@@ -915,8 +915,8 @@
         </p:nvSpPr>
         <p:spPr>
           <a:xfrm>
-            <a:off x="10436352" y="6556248"/>
-            <a:ext cx="1377696" cy="185166"/>
+            <a:off x="7827264" y="4917186"/>
+            <a:ext cx="1033272" cy="138874"/>
           </a:xfrm>
           <a:prstGeom prst="rect">
             <a:avLst/>
@@ -926,7 +926,7 @@
           <a:bodyPr vert="horz" lIns="0" tIns="0" rIns="0" bIns="0" anchor="ctr"/>
           <a:lstStyle>
             <a:lvl1pPr algn="r">
-              <a:defRPr sz="900">
+              <a:defRPr sz="700">
                 <a:solidFill>
                   <a:srgbClr val="00357A"/>
                 </a:solidFill>
@@ -953,8 +953,8 @@
         </p:nvSpPr>
         <p:spPr>
           <a:xfrm>
-            <a:off x="560832" y="6556248"/>
-            <a:ext cx="4145280" cy="185166"/>
+            <a:off x="420624" y="4917186"/>
+            <a:ext cx="3108960" cy="138874"/>
           </a:xfrm>
           <a:prstGeom prst="rect">
             <a:avLst/>
@@ -964,7 +964,7 @@
           <a:bodyPr vert="horz" lIns="0" tIns="0" rIns="0" bIns="0" anchor="ctr"/>
           <a:lstStyle>
             <a:lvl1pPr algn="l">
-              <a:defRPr sz="900">
+              <a:defRPr sz="700">
                 <a:solidFill>
                   <a:srgbClr val="00357A"/>
                 </a:solidFill>
@@ -1042,8 +1042,8 @@
         </p:nvSpPr>
         <p:spPr>
           <a:xfrm>
-            <a:off x="731520" y="1143229"/>
-            <a:ext cx="10728960" cy="5181219"/>
+            <a:off x="548640" y="857421"/>
+            <a:ext cx="8046720" cy="3885914"/>
           </a:xfrm>
           <a:prstGeom prst="rect">
             <a:avLst/>
@@ -1072,15 +1072,15 @@
         </p:nvSpPr>
         <p:spPr>
           <a:xfrm>
-            <a:off x="12192" y="6480810"/>
-            <a:ext cx="475488" cy="363474"/>
+            <a:off x="9144" y="4860608"/>
+            <a:ext cx="356616" cy="272606"/>
           </a:xfrm>
         </p:spPr>
         <p:txBody>
           <a:bodyPr anchor="ctr"/>
           <a:lstStyle>
             <a:lvl1pPr algn="ctr">
-              <a:defRPr sz="900" b="1">
+              <a:defRPr sz="700" b="1">
                 <a:solidFill>
                   <a:schemeClr val="tx1"/>
                 </a:solidFill>
@@ -1107,8 +1107,8 @@
         </p:nvSpPr>
         <p:spPr>
           <a:xfrm>
-            <a:off x="10436352" y="6556248"/>
-            <a:ext cx="1377696" cy="185166"/>
+            <a:off x="7827264" y="4917186"/>
+            <a:ext cx="1033272" cy="138874"/>
           </a:xfrm>
           <a:prstGeom prst="rect">
             <a:avLst/>
@@ -1118,7 +1118,7 @@
           <a:bodyPr vert="horz" lIns="0" tIns="0" rIns="0" bIns="0" anchor="ctr"/>
           <a:lstStyle>
             <a:lvl1pPr algn="r">
-              <a:defRPr sz="900">
+              <a:defRPr sz="700">
                 <a:solidFill>
                   <a:schemeClr val="tx1"/>
                 </a:solidFill>
@@ -1145,8 +1145,8 @@
         </p:nvSpPr>
         <p:spPr>
           <a:xfrm>
-            <a:off x="560832" y="6556248"/>
-            <a:ext cx="4145280" cy="185166"/>
+            <a:off x="420624" y="4917186"/>
+            <a:ext cx="3108960" cy="138874"/>
           </a:xfrm>
           <a:prstGeom prst="rect">
             <a:avLst/>
@@ -1156,7 +1156,7 @@
           <a:bodyPr vert="horz" lIns="0" tIns="0" rIns="0" bIns="0" anchor="ctr"/>
           <a:lstStyle>
             <a:lvl1pPr algn="l">
-              <a:defRPr sz="900">
+              <a:defRPr sz="700">
                 <a:solidFill>
                   <a:schemeClr val="tx1"/>
                 </a:solidFill>
@@ -1213,7 +1213,7 @@
         <p:spPr>
           <a:xfrm>
             <a:off x="0" y="0"/>
-            <a:ext cx="12192000" cy="6858000"/>
+            <a:ext cx="9144000" cy="5143500"/>
           </a:xfrm>
           <a:custGeom>
             <a:avLst/>
@@ -1272,7 +1272,7 @@
         <p:spPr>
           <a:xfrm>
             <a:off x="0" y="0"/>
-            <a:ext cx="12192000" cy="6858000"/>
+            <a:ext cx="9144000" cy="5143500"/>
           </a:xfrm>
           <a:custGeom>
             <a:avLst/>
@@ -1331,7 +1331,7 @@
         <p:spPr>
           <a:xfrm>
             <a:off x="0" y="0"/>
-            <a:ext cx="12192000" cy="6858000"/>
+            <a:ext cx="9144000" cy="5143500"/>
           </a:xfrm>
           <a:custGeom>
             <a:avLst/>
@@ -1358,7 +1358,7 @@
             </a:pathLst>
           </a:custGeom>
           <a:noFill/>
-          <a:ln w="18288">
+          <a:ln w="13716">
             <a:solidFill>
               <a:schemeClr val="accent1"/>
             </a:solidFill>
@@ -1374,7 +1374,7 @@
         <p:spPr>
           <a:xfrm>
             <a:off x="0" y="0"/>
-            <a:ext cx="12192000" cy="6858000"/>
+            <a:ext cx="9144000" cy="5143500"/>
           </a:xfrm>
           <a:custGeom>
             <a:avLst/>
@@ -1401,7 +1401,7 @@
             </a:pathLst>
           </a:custGeom>
           <a:noFill/>
-          <a:ln w="18288">
+          <a:ln w="13716">
             <a:solidFill>
               <a:schemeClr val="accent1"/>
             </a:solidFill>
@@ -1417,7 +1417,7 @@
         <p:spPr>
           <a:xfrm>
             <a:off x="0" y="0"/>
-            <a:ext cx="12192000" cy="6858000"/>
+            <a:ext cx="9144000" cy="5143500"/>
           </a:xfrm>
           <a:custGeom>
             <a:avLst/>
@@ -1444,7 +1444,7 @@
             </a:pathLst>
           </a:custGeom>
           <a:noFill/>
-          <a:ln w="18288">
+          <a:ln w="13716">
             <a:solidFill>
               <a:schemeClr val="accent1"/>
             </a:solidFill>
@@ -1467,8 +1467,8 @@
         </p:blipFill>
         <p:spPr>
           <a:xfrm>
-            <a:off x="731520" y="548640"/>
-            <a:ext cx="2157984" cy="548640"/>
+            <a:off x="548640" y="411480"/>
+            <a:ext cx="1618488" cy="411480"/>
           </a:xfrm>
           <a:prstGeom prst="rect">
             <a:avLst/>
@@ -1487,8 +1487,8 @@
         </p:nvSpPr>
         <p:spPr>
           <a:xfrm>
-            <a:off x="731520" y="2758288"/>
-            <a:ext cx="7559040" cy="822960"/>
+            <a:off x="548640" y="2068716"/>
+            <a:ext cx="5669280" cy="617220"/>
           </a:xfrm>
           <a:prstGeom prst="rect">
             <a:avLst/>
@@ -1503,7 +1503,7 @@
               <a:lnSpc>
                 <a:spcPct val="90000"/>
               </a:lnSpc>
-              <a:defRPr sz="4000" b="1" cap="none" baseline="0">
+              <a:defRPr sz="3000" b="1" cap="none" baseline="0">
                 <a:solidFill>
                   <a:srgbClr val="FFFFFF"/>
                 </a:solidFill>
@@ -1531,8 +1531,8 @@
         </p:nvSpPr>
         <p:spPr>
           <a:xfrm>
-            <a:off x="731520" y="3649828"/>
-            <a:ext cx="7559040" cy="912114"/>
+            <a:off x="548640" y="2737371"/>
+            <a:ext cx="5669280" cy="684086"/>
           </a:xfrm>
           <a:prstGeom prst="rect">
             <a:avLst/>
@@ -1548,7 +1548,7 @@
                 <a:spcPts val="0"/>
               </a:spcBef>
               <a:buNone/>
-              <a:defRPr sz="2000" b="0">
+              <a:defRPr sz="1500" b="0">
                 <a:solidFill>
                   <a:srgbClr val="FFFFFF"/>
                 </a:solidFill>
@@ -1576,15 +1576,15 @@
         </p:nvSpPr>
         <p:spPr>
           <a:xfrm>
-            <a:off x="12192" y="6480810"/>
-            <a:ext cx="475488" cy="363474"/>
+            <a:off x="9144" y="4860608"/>
+            <a:ext cx="356616" cy="272606"/>
           </a:xfrm>
         </p:spPr>
         <p:txBody>
           <a:bodyPr anchor="ctr"/>
           <a:lstStyle>
             <a:lvl1pPr algn="ctr">
-              <a:defRPr sz="900" b="1">
+              <a:defRPr sz="700" b="1">
                 <a:solidFill>
                   <a:srgbClr val="FFFFFF"/>
                 </a:solidFill>
@@ -1611,8 +1611,8 @@
         </p:nvSpPr>
         <p:spPr>
           <a:xfrm>
-            <a:off x="10436352" y="6556248"/>
-            <a:ext cx="1377696" cy="185166"/>
+            <a:off x="7827264" y="4917186"/>
+            <a:ext cx="1033272" cy="138874"/>
           </a:xfrm>
           <a:prstGeom prst="rect">
             <a:avLst/>
@@ -1622,7 +1622,7 @@
           <a:bodyPr vert="horz" lIns="0" tIns="0" rIns="0" bIns="0" anchor="ctr"/>
           <a:lstStyle>
             <a:lvl1pPr algn="r">
-              <a:defRPr sz="900">
+              <a:defRPr sz="700">
                 <a:solidFill>
                   <a:srgbClr val="FFFFFF"/>
                 </a:solidFill>
@@ -1649,8 +1649,8 @@
         </p:nvSpPr>
         <p:spPr>
           <a:xfrm>
-            <a:off x="560832" y="6556248"/>
-            <a:ext cx="4145280" cy="185166"/>
+            <a:off x="420624" y="4917186"/>
+            <a:ext cx="3108960" cy="138874"/>
           </a:xfrm>
           <a:prstGeom prst="rect">
             <a:avLst/>
@@ -1660,7 +1660,7 @@
           <a:bodyPr vert="horz" lIns="0" tIns="0" rIns="0" bIns="0" anchor="ctr"/>
           <a:lstStyle>
             <a:lvl1pPr algn="l">
-              <a:defRPr sz="900">
+              <a:defRPr sz="700">
                 <a:solidFill>
                   <a:srgbClr val="FFFFFF"/>
                 </a:solidFill>
@@ -1738,8 +1738,8 @@
         </p:nvSpPr>
         <p:spPr>
           <a:xfrm>
-            <a:off x="731520" y="1143229"/>
-            <a:ext cx="5181600" cy="5181219"/>
+            <a:off x="548640" y="857421"/>
+            <a:ext cx="3886200" cy="3885914"/>
           </a:xfrm>
           <a:prstGeom prst="rect">
             <a:avLst/>
@@ -1768,8 +1768,8 @@
         </p:nvSpPr>
         <p:spPr>
           <a:xfrm>
-            <a:off x="6278880" y="1143229"/>
-            <a:ext cx="5181600" cy="5181219"/>
+            <a:off x="4709160" y="857421"/>
+            <a:ext cx="3886200" cy="3885914"/>
           </a:xfrm>
           <a:prstGeom prst="rect">
             <a:avLst/>
@@ -1798,15 +1798,15 @@
         </p:nvSpPr>
         <p:spPr>
           <a:xfrm>
-            <a:off x="12192" y="6480810"/>
-            <a:ext cx="475488" cy="363474"/>
+            <a:off x="9144" y="4860608"/>
+            <a:ext cx="356616" cy="272606"/>
           </a:xfrm>
         </p:spPr>
         <p:txBody>
           <a:bodyPr anchor="ctr"/>
           <a:lstStyle>
             <a:lvl1pPr algn="ctr">
-              <a:defRPr sz="900" b="1">
+              <a:defRPr sz="700" b="1">
                 <a:solidFill>
                   <a:schemeClr val="tx1"/>
                 </a:solidFill>
@@ -1833,8 +1833,8 @@
         </p:nvSpPr>
         <p:spPr>
           <a:xfrm>
-            <a:off x="10436352" y="6556248"/>
-            <a:ext cx="1377696" cy="185166"/>
+            <a:off x="7827264" y="4917186"/>
+            <a:ext cx="1033272" cy="138874"/>
           </a:xfrm>
           <a:prstGeom prst="rect">
             <a:avLst/>
@@ -1844,7 +1844,7 @@
           <a:bodyPr vert="horz" lIns="0" tIns="0" rIns="0" bIns="0" anchor="ctr"/>
           <a:lstStyle>
             <a:lvl1pPr algn="r">
-              <a:defRPr sz="900">
+              <a:defRPr sz="700">
                 <a:solidFill>
                   <a:schemeClr val="tx1"/>
                 </a:solidFill>
@@ -1871,8 +1871,8 @@
         </p:nvSpPr>
         <p:spPr>
           <a:xfrm>
-            <a:off x="560832" y="6556248"/>
-            <a:ext cx="4145280" cy="185166"/>
+            <a:off x="420624" y="4917186"/>
+            <a:ext cx="3108960" cy="138874"/>
           </a:xfrm>
           <a:prstGeom prst="rect">
             <a:avLst/>
@@ -1882,7 +1882,7 @@
           <a:bodyPr vert="horz" lIns="0" tIns="0" rIns="0" bIns="0" anchor="ctr"/>
           <a:lstStyle>
             <a:lvl1pPr algn="l">
-              <a:defRPr sz="900">
+              <a:defRPr sz="700">
                 <a:solidFill>
                   <a:schemeClr val="tx1"/>
                 </a:solidFill>
@@ -1960,8 +1960,8 @@
         </p:nvSpPr>
         <p:spPr>
           <a:xfrm>
-            <a:off x="731520" y="1143229"/>
-            <a:ext cx="5181600" cy="617220"/>
+            <a:off x="548640" y="857421"/>
+            <a:ext cx="3886200" cy="462915"/>
           </a:xfrm>
           <a:prstGeom prst="rect">
             <a:avLst/>
@@ -1974,7 +1974,7 @@
           <a:lstStyle>
             <a:lvl1pPr marL="0" indent="0">
               <a:buNone/>
-              <a:defRPr sz="2000" b="1">
+              <a:defRPr sz="1500" b="1">
                 <a:solidFill>
                   <a:schemeClr val="tx2"/>
                 </a:solidFill>
@@ -2001,8 +2001,8 @@
         </p:nvSpPr>
         <p:spPr>
           <a:xfrm>
-            <a:off x="731520" y="1829029"/>
-            <a:ext cx="5181600" cy="4495419"/>
+            <a:off x="548640" y="1371771"/>
+            <a:ext cx="3886200" cy="3371564"/>
           </a:xfrm>
           <a:prstGeom prst="rect">
             <a:avLst/>
@@ -2031,8 +2031,8 @@
         </p:nvSpPr>
         <p:spPr>
           <a:xfrm>
-            <a:off x="6278880" y="1143229"/>
-            <a:ext cx="5181600" cy="617220"/>
+            <a:off x="4709160" y="857421"/>
+            <a:ext cx="3886200" cy="462915"/>
           </a:xfrm>
           <a:prstGeom prst="rect">
             <a:avLst/>
@@ -2045,7 +2045,7 @@
           <a:lstStyle>
             <a:lvl1pPr marL="0" indent="0">
               <a:buNone/>
-              <a:defRPr sz="2000" b="1">
+              <a:defRPr sz="1500" b="1">
                 <a:solidFill>
                   <a:schemeClr val="tx2"/>
                 </a:solidFill>
@@ -2072,8 +2072,8 @@
         </p:nvSpPr>
         <p:spPr>
           <a:xfrm>
-            <a:off x="6278880" y="1829029"/>
-            <a:ext cx="5181600" cy="4495419"/>
+            <a:off x="4709160" y="1371771"/>
+            <a:ext cx="3886200" cy="3371564"/>
           </a:xfrm>
           <a:prstGeom prst="rect">
             <a:avLst/>
@@ -2102,15 +2102,15 @@
         </p:nvSpPr>
         <p:spPr>
           <a:xfrm>
-            <a:off x="12192" y="6480810"/>
-            <a:ext cx="475488" cy="363474"/>
+            <a:off x="9144" y="4860608"/>
+            <a:ext cx="356616" cy="272606"/>
           </a:xfrm>
         </p:spPr>
         <p:txBody>
           <a:bodyPr anchor="ctr"/>
           <a:lstStyle>
             <a:lvl1pPr algn="ctr">
-              <a:defRPr sz="900" b="1">
+              <a:defRPr sz="700" b="1">
                 <a:solidFill>
                   <a:schemeClr val="tx1"/>
                 </a:solidFill>
@@ -2137,8 +2137,8 @@
         </p:nvSpPr>
         <p:spPr>
           <a:xfrm>
-            <a:off x="10436352" y="6556248"/>
-            <a:ext cx="1377696" cy="185166"/>
+            <a:off x="7827264" y="4917186"/>
+            <a:ext cx="1033272" cy="138874"/>
           </a:xfrm>
           <a:prstGeom prst="rect">
             <a:avLst/>
@@ -2148,7 +2148,7 @@
           <a:bodyPr vert="horz" lIns="0" tIns="0" rIns="0" bIns="0" anchor="ctr"/>
           <a:lstStyle>
             <a:lvl1pPr algn="r">
-              <a:defRPr sz="900">
+              <a:defRPr sz="700">
                 <a:solidFill>
                   <a:schemeClr val="tx1"/>
                 </a:solidFill>
@@ -2175,8 +2175,8 @@
         </p:nvSpPr>
         <p:spPr>
           <a:xfrm>
-            <a:off x="560832" y="6556248"/>
-            <a:ext cx="4145280" cy="185166"/>
+            <a:off x="420624" y="4917186"/>
+            <a:ext cx="3108960" cy="138874"/>
           </a:xfrm>
           <a:prstGeom prst="rect">
             <a:avLst/>
@@ -2186,7 +2186,7 @@
           <a:bodyPr vert="horz" lIns="0" tIns="0" rIns="0" bIns="0" anchor="ctr"/>
           <a:lstStyle>
             <a:lvl1pPr algn="l">
-              <a:defRPr sz="900">
+              <a:defRPr sz="700">
                 <a:solidFill>
                   <a:schemeClr val="tx1"/>
                 </a:solidFill>
@@ -2238,8 +2238,8 @@
         </p:nvSpPr>
         <p:spPr>
           <a:xfrm>
-            <a:off x="731520" y="1143229"/>
-            <a:ext cx="4023360" cy="891540"/>
+            <a:off x="548640" y="857421"/>
+            <a:ext cx="3017520" cy="668655"/>
           </a:xfrm>
           <a:prstGeom prst="rect">
             <a:avLst/>
@@ -2251,7 +2251,7 @@
           </a:bodyPr>
           <a:lstStyle>
             <a:lvl1pPr algn="l">
-              <a:defRPr sz="2000" b="1"/>
+              <a:defRPr sz="1500" b="1"/>
             </a:lvl1pPr>
           </a:lstStyle>
           <a:p>
@@ -2274,8 +2274,8 @@
         </p:nvSpPr>
         <p:spPr>
           <a:xfrm>
-            <a:off x="5120640" y="1143229"/>
-            <a:ext cx="6339840" cy="5181219"/>
+            <a:off x="3840480" y="857421"/>
+            <a:ext cx="4754880" cy="3885914"/>
           </a:xfrm>
           <a:prstGeom prst="rect">
             <a:avLst/>
@@ -2304,8 +2304,8 @@
         </p:nvSpPr>
         <p:spPr>
           <a:xfrm>
-            <a:off x="731520" y="2103349"/>
-            <a:ext cx="4023360" cy="4221099"/>
+            <a:off x="548640" y="1577511"/>
+            <a:ext cx="3017520" cy="3165824"/>
           </a:xfrm>
           <a:prstGeom prst="rect">
             <a:avLst/>
@@ -2318,7 +2318,7 @@
           <a:lstStyle>
             <a:lvl1pPr marL="0" indent="0">
               <a:buNone/>
-              <a:defRPr sz="1300"/>
+              <a:defRPr sz="1000"/>
             </a:lvl1pPr>
           </a:lstStyle>
           <a:p>
@@ -2341,15 +2341,15 @@
         </p:nvSpPr>
         <p:spPr>
           <a:xfrm>
-            <a:off x="12192" y="6480810"/>
-            <a:ext cx="475488" cy="363474"/>
+            <a:off x="9144" y="4860608"/>
+            <a:ext cx="356616" cy="272606"/>
           </a:xfrm>
         </p:spPr>
         <p:txBody>
           <a:bodyPr anchor="ctr"/>
           <a:lstStyle>
             <a:lvl1pPr algn="ctr">
-              <a:defRPr sz="900" b="1">
+              <a:defRPr sz="700" b="1">
                 <a:solidFill>
                   <a:schemeClr val="tx1"/>
                 </a:solidFill>
@@ -2376,8 +2376,8 @@
         </p:nvSpPr>
         <p:spPr>
           <a:xfrm>
-            <a:off x="10436352" y="6556248"/>
-            <a:ext cx="1377696" cy="185166"/>
+            <a:off x="7827264" y="4917186"/>
+            <a:ext cx="1033272" cy="138874"/>
           </a:xfrm>
           <a:prstGeom prst="rect">
             <a:avLst/>
@@ -2387,7 +2387,7 @@
           <a:bodyPr vert="horz" lIns="0" tIns="0" rIns="0" bIns="0" anchor="ctr"/>
           <a:lstStyle>
             <a:lvl1pPr algn="r">
-              <a:defRPr sz="900">
+              <a:defRPr sz="700">
                 <a:solidFill>
                   <a:schemeClr val="tx1"/>
                 </a:solidFill>
@@ -2414,8 +2414,8 @@
         </p:nvSpPr>
         <p:spPr>
           <a:xfrm>
-            <a:off x="560832" y="6556248"/>
-            <a:ext cx="4145280" cy="185166"/>
+            <a:off x="420624" y="4917186"/>
+            <a:ext cx="3108960" cy="138874"/>
           </a:xfrm>
           <a:prstGeom prst="rect">
             <a:avLst/>
@@ -2425,7 +2425,7 @@
           <a:bodyPr vert="horz" lIns="0" tIns="0" rIns="0" bIns="0" anchor="ctr"/>
           <a:lstStyle>
             <a:lvl1pPr algn="l">
-              <a:defRPr sz="900">
+              <a:defRPr sz="700">
                 <a:solidFill>
                   <a:schemeClr val="tx1"/>
                 </a:solidFill>
@@ -2477,15 +2477,15 @@
         </p:nvSpPr>
         <p:spPr>
           <a:xfrm>
-            <a:off x="12192" y="6480810"/>
-            <a:ext cx="475488" cy="363474"/>
+            <a:off x="9144" y="4860608"/>
+            <a:ext cx="356616" cy="272606"/>
           </a:xfrm>
         </p:spPr>
         <p:txBody>
           <a:bodyPr anchor="ctr"/>
           <a:lstStyle>
             <a:lvl1pPr algn="ctr">
-              <a:defRPr sz="900" b="1">
+              <a:defRPr sz="700" b="1">
                 <a:solidFill>
                   <a:schemeClr val="tx1"/>
                 </a:solidFill>
@@ -2512,8 +2512,8 @@
         </p:nvSpPr>
         <p:spPr>
           <a:xfrm>
-            <a:off x="10436352" y="6556248"/>
-            <a:ext cx="1377696" cy="185166"/>
+            <a:off x="7827264" y="4917186"/>
+            <a:ext cx="1033272" cy="138874"/>
           </a:xfrm>
           <a:prstGeom prst="rect">
             <a:avLst/>
@@ -2523,7 +2523,7 @@
           <a:bodyPr vert="horz" lIns="0" tIns="0" rIns="0" bIns="0" anchor="ctr"/>
           <a:lstStyle>
             <a:lvl1pPr algn="r">
-              <a:defRPr sz="900">
+              <a:defRPr sz="700">
                 <a:solidFill>
                   <a:schemeClr val="tx1"/>
                 </a:solidFill>
@@ -2550,8 +2550,8 @@
         </p:nvSpPr>
         <p:spPr>
           <a:xfrm>
-            <a:off x="560832" y="6556248"/>
-            <a:ext cx="4145280" cy="185166"/>
+            <a:off x="420624" y="4917186"/>
+            <a:ext cx="3108960" cy="138874"/>
           </a:xfrm>
           <a:prstGeom prst="rect">
             <a:avLst/>
@@ -2561,7 +2561,7 @@
           <a:bodyPr vert="horz" lIns="0" tIns="0" rIns="0" bIns="0" anchor="ctr"/>
           <a:lstStyle>
             <a:lvl1pPr algn="l">
-              <a:defRPr sz="900">
+              <a:defRPr sz="700">
                 <a:solidFill>
                   <a:schemeClr val="tx1"/>
                 </a:solidFill>
@@ -2618,7 +2618,7 @@
         <p:spPr>
           <a:xfrm>
             <a:off x="0" y="0"/>
-            <a:ext cx="12192000" cy="6858000"/>
+            <a:ext cx="9144000" cy="5143500"/>
           </a:xfrm>
           <a:custGeom>
             <a:avLst/>
@@ -2677,7 +2677,7 @@
         <p:spPr>
           <a:xfrm>
             <a:off x="0" y="0"/>
-            <a:ext cx="12192000" cy="6858000"/>
+            <a:ext cx="9144000" cy="5143500"/>
           </a:xfrm>
           <a:custGeom>
             <a:avLst/>
@@ -2736,7 +2736,7 @@
         <p:spPr>
           <a:xfrm>
             <a:off x="0" y="0"/>
-            <a:ext cx="12192000" cy="6858000"/>
+            <a:ext cx="9144000" cy="5143500"/>
           </a:xfrm>
           <a:custGeom>
             <a:avLst/>
@@ -2763,7 +2763,7 @@
             </a:pathLst>
           </a:custGeom>
           <a:noFill/>
-          <a:ln w="18288">
+          <a:ln w="13716">
             <a:solidFill>
               <a:schemeClr val="accent1"/>
             </a:solidFill>
@@ -2779,7 +2779,7 @@
         <p:spPr>
           <a:xfrm>
             <a:off x="0" y="0"/>
-            <a:ext cx="12192000" cy="6858000"/>
+            <a:ext cx="9144000" cy="5143500"/>
           </a:xfrm>
           <a:custGeom>
             <a:avLst/>
@@ -2806,7 +2806,7 @@
             </a:pathLst>
           </a:custGeom>
           <a:noFill/>
-          <a:ln w="18288">
+          <a:ln w="13716">
             <a:solidFill>
               <a:schemeClr val="accent1"/>
             </a:solidFill>
@@ -2822,7 +2822,7 @@
         <p:spPr>
           <a:xfrm>
             <a:off x="0" y="0"/>
-            <a:ext cx="12192000" cy="6858000"/>
+            <a:ext cx="9144000" cy="5143500"/>
           </a:xfrm>
           <a:custGeom>
             <a:avLst/>
@@ -2849,7 +2849,7 @@
             </a:pathLst>
           </a:custGeom>
           <a:noFill/>
-          <a:ln w="18288">
+          <a:ln w="13716">
             <a:solidFill>
               <a:schemeClr val="accent1"/>
             </a:solidFill>
@@ -2872,8 +2872,8 @@
         </p:blipFill>
         <p:spPr>
           <a:xfrm>
-            <a:off x="731520" y="617220"/>
-            <a:ext cx="2698090" cy="685800"/>
+            <a:off x="548640" y="462915"/>
+            <a:ext cx="2023567" cy="514350"/>
           </a:xfrm>
           <a:prstGeom prst="rect">
             <a:avLst/>
@@ -2888,8 +2888,8 @@
         </p:nvSpPr>
         <p:spPr>
           <a:xfrm>
-            <a:off x="0" y="3154680"/>
-            <a:ext cx="219456" cy="514350"/>
+            <a:off x="0" y="2366010"/>
+            <a:ext cx="164592" cy="385762"/>
           </a:xfrm>
           <a:prstGeom prst="rect">
             <a:avLst/>
@@ -2914,8 +2914,8 @@
         </p:nvSpPr>
         <p:spPr>
           <a:xfrm>
-            <a:off x="731520" y="1508760"/>
-            <a:ext cx="7559040" cy="2263140"/>
+            <a:off x="548640" y="1131570"/>
+            <a:ext cx="5669280" cy="1697355"/>
           </a:xfrm>
           <a:prstGeom prst="rect">
             <a:avLst/>
@@ -2930,7 +2930,7 @@
               <a:lnSpc>
                 <a:spcPct val="90000"/>
               </a:lnSpc>
-              <a:defRPr sz="4000" b="1">
+              <a:defRPr sz="3000" b="1">
                 <a:solidFill>
                   <a:srgbClr val="FFFFFF"/>
                 </a:solidFill>
@@ -2958,8 +2958,8 @@
         </p:nvSpPr>
         <p:spPr>
           <a:xfrm>
-            <a:off x="731520" y="3977640"/>
-            <a:ext cx="7559040" cy="2057400"/>
+            <a:off x="548640" y="2983230"/>
+            <a:ext cx="5669280" cy="1543050"/>
           </a:xfrm>
           <a:prstGeom prst="rect">
             <a:avLst/>
@@ -2971,21 +2971,21 @@
           </a:bodyPr>
           <a:lstStyle>
             <a:lvl1pPr>
-              <a:defRPr sz="1600">
+              <a:defRPr sz="1200">
                 <a:solidFill>
                   <a:srgbClr val="FFFFFF"/>
                 </a:solidFill>
               </a:defRPr>
             </a:lvl1pPr>
             <a:lvl2pPr>
-              <a:defRPr sz="1500">
+              <a:defRPr sz="1100">
                 <a:solidFill>
                   <a:srgbClr val="FFFFFF"/>
                 </a:solidFill>
               </a:defRPr>
             </a:lvl2pPr>
             <a:lvl3pPr>
-              <a:defRPr sz="1300">
+              <a:defRPr sz="1000">
                 <a:solidFill>
                   <a:srgbClr val="FFFFFF"/>
                 </a:solidFill>
@@ -3012,15 +3012,15 @@
         </p:nvSpPr>
         <p:spPr>
           <a:xfrm>
-            <a:off x="12192" y="6480810"/>
-            <a:ext cx="475488" cy="363474"/>
+            <a:off x="9144" y="4860608"/>
+            <a:ext cx="356616" cy="272606"/>
           </a:xfrm>
         </p:spPr>
         <p:txBody>
           <a:bodyPr anchor="ctr"/>
           <a:lstStyle>
             <a:lvl1pPr algn="ctr">
-              <a:defRPr sz="900" b="1">
+              <a:defRPr sz="700" b="1">
                 <a:solidFill>
                   <a:srgbClr val="FFFFFF"/>
                 </a:solidFill>
@@ -3047,8 +3047,8 @@
         </p:nvSpPr>
         <p:spPr>
           <a:xfrm>
-            <a:off x="10436352" y="6556248"/>
-            <a:ext cx="1377696" cy="185166"/>
+            <a:off x="7827264" y="4917186"/>
+            <a:ext cx="1033272" cy="138874"/>
           </a:xfrm>
           <a:prstGeom prst="rect">
             <a:avLst/>
@@ -3058,7 +3058,7 @@
           <a:bodyPr vert="horz" lIns="0" tIns="0" rIns="0" bIns="0" anchor="ctr"/>
           <a:lstStyle>
             <a:lvl1pPr algn="r">
-              <a:defRPr sz="900">
+              <a:defRPr sz="700">
                 <a:solidFill>
                   <a:srgbClr val="FFFFFF"/>
                 </a:solidFill>
@@ -3085,8 +3085,8 @@
         </p:nvSpPr>
         <p:spPr>
           <a:xfrm>
-            <a:off x="560832" y="6556248"/>
-            <a:ext cx="4145280" cy="185166"/>
+            <a:off x="420624" y="4917186"/>
+            <a:ext cx="3108960" cy="138874"/>
           </a:xfrm>
           <a:prstGeom prst="rect">
             <a:avLst/>
@@ -3096,7 +3096,7 @@
           <a:bodyPr vert="horz" lIns="0" tIns="0" rIns="0" bIns="0" anchor="ctr"/>
           <a:lstStyle>
             <a:lvl1pPr algn="l">
-              <a:defRPr sz="900">
+              <a:defRPr sz="700">
                 <a:solidFill>
                   <a:srgbClr val="FFFFFF"/>
                 </a:solidFill>
@@ -3153,7 +3153,7 @@
         <p:spPr>
           <a:xfrm>
             <a:off x="0" y="0"/>
-            <a:ext cx="12192000" cy="6858000"/>
+            <a:ext cx="9144000" cy="5143500"/>
           </a:xfrm>
           <a:custGeom>
             <a:avLst/>
@@ -3180,7 +3180,7 @@
             </a:pathLst>
           </a:custGeom>
           <a:noFill/>
-          <a:ln w="18288">
+          <a:ln w="13716">
             <a:solidFill>
               <a:schemeClr val="accent1"/>
             </a:solidFill>
@@ -3196,7 +3196,7 @@
         <p:spPr>
           <a:xfrm>
             <a:off x="0" y="0"/>
-            <a:ext cx="12192000" cy="6858000"/>
+            <a:ext cx="9144000" cy="5143500"/>
           </a:xfrm>
           <a:custGeom>
             <a:avLst/>
@@ -3223,7 +3223,7 @@
             </a:pathLst>
           </a:custGeom>
           <a:noFill/>
-          <a:ln w="18288">
+          <a:ln w="13716">
             <a:solidFill>
               <a:schemeClr val="accent1"/>
             </a:solidFill>
@@ -3239,7 +3239,7 @@
         <p:spPr>
           <a:xfrm>
             <a:off x="0" y="0"/>
-            <a:ext cx="12192000" cy="6858000"/>
+            <a:ext cx="9144000" cy="5143500"/>
           </a:xfrm>
           <a:custGeom>
             <a:avLst/>
@@ -3266,7 +3266,7 @@
             </a:pathLst>
           </a:custGeom>
           <a:noFill/>
-          <a:ln w="18288">
+          <a:ln w="13716">
             <a:solidFill>
               <a:schemeClr val="accent1"/>
             </a:solidFill>
@@ -3289,8 +3289,8 @@
         </p:blipFill>
         <p:spPr>
           <a:xfrm>
-            <a:off x="731520" y="411480"/>
-            <a:ext cx="2428646" cy="617220"/>
+            <a:off x="548640" y="308610"/>
+            <a:ext cx="1821485" cy="462915"/>
           </a:xfrm>
           <a:prstGeom prst="rect">
             <a:avLst/>
@@ -3305,8 +3305,8 @@
         </p:nvSpPr>
         <p:spPr>
           <a:xfrm>
-            <a:off x="0" y="2948940"/>
-            <a:ext cx="219456" cy="1097280"/>
+            <a:off x="0" y="2211705"/>
+            <a:ext cx="164592" cy="822960"/>
           </a:xfrm>
           <a:prstGeom prst="rect">
             <a:avLst/>
@@ -3331,8 +3331,8 @@
         </p:nvSpPr>
         <p:spPr>
           <a:xfrm>
-            <a:off x="731520" y="2571750"/>
-            <a:ext cx="6096000" cy="308610"/>
+            <a:off x="548640" y="1928812"/>
+            <a:ext cx="4572000" cy="231458"/>
           </a:xfrm>
           <a:prstGeom prst="rect">
             <a:avLst/>
@@ -3348,7 +3348,7 @@
                 <a:spcPts val="0"/>
               </a:spcBef>
               <a:buNone/>
-              <a:defRPr sz="1100" b="1" cap="all">
+              <a:defRPr sz="800" b="1" cap="all">
                 <a:solidFill>
                   <a:srgbClr val="00357A"/>
                 </a:solidFill>
@@ -3376,8 +3376,8 @@
         </p:nvSpPr>
         <p:spPr>
           <a:xfrm>
-            <a:off x="731520" y="2948940"/>
-            <a:ext cx="6096000" cy="1097280"/>
+            <a:off x="548640" y="2211705"/>
+            <a:ext cx="4572000" cy="822960"/>
           </a:xfrm>
           <a:prstGeom prst="rect">
             <a:avLst/>
@@ -3393,7 +3393,7 @@
                 <a:spcPts val="0"/>
               </a:spcBef>
               <a:buNone/>
-              <a:defRPr sz="2900" b="1">
+              <a:defRPr sz="2200" b="1">
                 <a:solidFill>
                   <a:srgbClr val="00357A"/>
                 </a:solidFill>
@@ -3417,13 +3417,13 @@
         </p:nvCxnSpPr>
         <p:spPr>
           <a:xfrm>
-            <a:off x="731520" y="4217670"/>
-            <a:ext cx="1584960" cy="0"/>
+            <a:off x="548640" y="3163252"/>
+            <a:ext cx="1188720" cy="0"/>
           </a:xfrm>
           <a:prstGeom prst="line">
             <a:avLst/>
           </a:prstGeom>
-          <a:ln w="22631">
+          <a:ln w="16974">
             <a:solidFill>
               <a:schemeClr val="accent1"/>
             </a:solidFill>
@@ -3442,8 +3442,8 @@
         </p:nvSpPr>
         <p:spPr>
           <a:xfrm>
-            <a:off x="731520" y="4389120"/>
-            <a:ext cx="6096000" cy="1508760"/>
+            <a:off x="548640" y="3291840"/>
+            <a:ext cx="4572000" cy="1131570"/>
           </a:xfrm>
           <a:prstGeom prst="rect">
             <a:avLst/>
@@ -3459,7 +3459,7 @@
                 <a:spcPts val="0"/>
               </a:spcBef>
               <a:buNone/>
-              <a:defRPr sz="2000" b="0">
+              <a:defRPr sz="1500" b="0">
                 <a:solidFill>
                   <a:srgbClr val="00357A"/>
                 </a:solidFill>
@@ -3487,15 +3487,15 @@
         </p:nvSpPr>
         <p:spPr>
           <a:xfrm>
-            <a:off x="12192" y="6480810"/>
-            <a:ext cx="475488" cy="363474"/>
+            <a:off x="9144" y="4860608"/>
+            <a:ext cx="356616" cy="272606"/>
           </a:xfrm>
         </p:spPr>
         <p:txBody>
           <a:bodyPr anchor="ctr"/>
           <a:lstStyle>
             <a:lvl1pPr algn="ctr">
-              <a:defRPr sz="900" b="1">
+              <a:defRPr sz="700" b="1">
                 <a:solidFill>
                   <a:srgbClr val="00357A"/>
                 </a:solidFill>
@@ -3522,8 +3522,8 @@
         </p:nvSpPr>
         <p:spPr>
           <a:xfrm>
-            <a:off x="560832" y="6556248"/>
-            <a:ext cx="4145280" cy="185166"/>
+            <a:off x="420624" y="4917186"/>
+            <a:ext cx="3108960" cy="138874"/>
           </a:xfrm>
           <a:prstGeom prst="rect">
             <a:avLst/>
@@ -3533,7 +3533,7 @@
           <a:bodyPr vert="horz" lIns="0" tIns="0" rIns="0" bIns="0" anchor="ctr"/>
           <a:lstStyle>
             <a:lvl1pPr algn="l">
-              <a:defRPr sz="900">
+              <a:defRPr sz="700">
                 <a:solidFill>
                   <a:srgbClr val="00357A"/>
                 </a:solidFill>
@@ -3587,7 +3587,7 @@
         <p:spPr>
           <a:xfrm>
             <a:off x="0" y="0"/>
-            <a:ext cx="12192000" cy="6858000"/>
+            <a:ext cx="9144000" cy="5143500"/>
           </a:xfrm>
           <a:custGeom>
             <a:avLst/>
@@ -3614,7 +3614,7 @@
             </a:pathLst>
           </a:custGeom>
           <a:noFill/>
-          <a:ln w="18288">
+          <a:ln w="13716">
             <a:solidFill>
               <a:schemeClr val="lt2"/>
             </a:solidFill>
@@ -3630,7 +3630,7 @@
         <p:spPr>
           <a:xfrm>
             <a:off x="0" y="0"/>
-            <a:ext cx="12192000" cy="6858000"/>
+            <a:ext cx="9144000" cy="5143500"/>
           </a:xfrm>
           <a:custGeom>
             <a:avLst/>
@@ -3657,7 +3657,7 @@
             </a:pathLst>
           </a:custGeom>
           <a:noFill/>
-          <a:ln w="18288">
+          <a:ln w="13716">
             <a:solidFill>
               <a:schemeClr val="lt2"/>
             </a:solidFill>
@@ -3673,7 +3673,7 @@
         <p:spPr>
           <a:xfrm>
             <a:off x="0" y="0"/>
-            <a:ext cx="12192000" cy="6858000"/>
+            <a:ext cx="9144000" cy="5143500"/>
           </a:xfrm>
           <a:custGeom>
             <a:avLst/>
@@ -3700,7 +3700,7 @@
             </a:pathLst>
           </a:custGeom>
           <a:noFill/>
-          <a:ln w="18288">
+          <a:ln w="13716">
             <a:solidFill>
               <a:schemeClr val="lt2"/>
             </a:solidFill>
@@ -3715,8 +3715,8 @@
         </p:nvSpPr>
         <p:spPr>
           <a:xfrm>
-            <a:off x="0" y="336042"/>
-            <a:ext cx="219456" cy="654253"/>
+            <a:off x="0" y="252032"/>
+            <a:ext cx="164592" cy="490690"/>
           </a:xfrm>
           <a:prstGeom prst="rect">
             <a:avLst/>
@@ -3737,8 +3737,8 @@
         </p:nvCxnSpPr>
         <p:spPr>
           <a:xfrm>
-            <a:off x="731520" y="990295"/>
-            <a:ext cx="10728960" cy="0"/>
+            <a:off x="548640" y="742721"/>
+            <a:ext cx="8046720" cy="0"/>
           </a:xfrm>
           <a:prstGeom prst="line">
             <a:avLst/>
@@ -3764,8 +3764,8 @@
         </p:nvSpPr>
         <p:spPr>
           <a:xfrm>
-            <a:off x="731520" y="336042"/>
-            <a:ext cx="8686688" cy="654253"/>
+            <a:off x="548640" y="252032"/>
+            <a:ext cx="6515016" cy="490690"/>
           </a:xfrm>
           <a:prstGeom prst="rect">
             <a:avLst/>
@@ -3796,15 +3796,15 @@
         </p:nvSpPr>
         <p:spPr>
           <a:xfrm>
-            <a:off x="731520" y="1143229"/>
-            <a:ext cx="10728960" cy="5181219"/>
-          </a:xfrm>
-          <a:prstGeom prst="rect">
-            <a:avLst/>
-          </a:prstGeom>
-        </p:spPr>
-        <p:txBody>
-          <a:bodyPr vert="horz" lIns="0" tIns="45720" rIns="0" bIns="45720">
+            <a:off x="548640" y="857421"/>
+            <a:ext cx="8046720" cy="3885914"/>
+          </a:xfrm>
+          <a:prstGeom prst="rect">
+            <a:avLst/>
+          </a:prstGeom>
+        </p:spPr>
+        <p:txBody>
+          <a:bodyPr vert="horz" lIns="0" tIns="34290" rIns="0" bIns="34290">
             <a:normAutofit/>
           </a:bodyPr>
           <a:lstStyle/>
@@ -3829,15 +3829,15 @@
         </p:nvSpPr>
         <p:spPr>
           <a:xfrm>
-            <a:off x="12192" y="6480810"/>
-            <a:ext cx="475488" cy="363474"/>
+            <a:off x="9144" y="4860608"/>
+            <a:ext cx="356616" cy="272606"/>
           </a:xfrm>
         </p:spPr>
         <p:txBody>
           <a:bodyPr anchor="ctr"/>
           <a:lstStyle>
             <a:lvl1pPr algn="ctr">
-              <a:defRPr sz="900" b="1">
+              <a:defRPr sz="700" b="1">
                 <a:solidFill>
                   <a:schemeClr val="tx1"/>
                 </a:solidFill>
@@ -3864,8 +3864,8 @@
         </p:nvSpPr>
         <p:spPr>
           <a:xfrm>
-            <a:off x="10436352" y="6556248"/>
-            <a:ext cx="1377696" cy="185166"/>
+            <a:off x="7827264" y="4917186"/>
+            <a:ext cx="1033272" cy="138874"/>
           </a:xfrm>
           <a:prstGeom prst="rect">
             <a:avLst/>
@@ -3875,7 +3875,7 @@
           <a:bodyPr vert="horz" lIns="0" tIns="0" rIns="0" bIns="0" anchor="ctr"/>
           <a:lstStyle>
             <a:lvl1pPr algn="r">
-              <a:defRPr sz="900">
+              <a:defRPr sz="700">
                 <a:solidFill>
                   <a:schemeClr val="tx1"/>
                 </a:solidFill>
@@ -3902,8 +3902,8 @@
         </p:nvSpPr>
         <p:spPr>
           <a:xfrm>
-            <a:off x="560832" y="6556248"/>
-            <a:ext cx="4145280" cy="185166"/>
+            <a:off x="420624" y="4917186"/>
+            <a:ext cx="3108960" cy="138874"/>
           </a:xfrm>
           <a:prstGeom prst="rect">
             <a:avLst/>
@@ -3913,7 +3913,7 @@
           <a:bodyPr vert="horz" lIns="0" tIns="0" rIns="0" bIns="0" anchor="ctr"/>
           <a:lstStyle>
             <a:lvl1pPr algn="l">
-              <a:defRPr sz="900">
+              <a:defRPr sz="700">
                 <a:solidFill>
                   <a:schemeClr val="tx1"/>
                 </a:solidFill>
@@ -3944,8 +3944,8 @@
         </p:blipFill>
         <p:spPr>
           <a:xfrm>
-            <a:off x="9723008" y="365531"/>
-            <a:ext cx="1737472" cy="441655"/>
+            <a:off x="7292256" y="274149"/>
+            <a:ext cx="1303104" cy="331241"/>
           </a:xfrm>
           <a:prstGeom prst="rect">
             <a:avLst/>
@@ -3969,12 +3969,12 @@
   </p:sldLayoutIdLst>
   <p:txStyles>
     <p:titleStyle>
-      <a:lvl1pPr algn="l" defTabSz="457200" rtl="0" eaLnBrk="1" latinLnBrk="0" hangingPunct="1">
+      <a:lvl1pPr algn="l" defTabSz="342900" rtl="0" eaLnBrk="1" latinLnBrk="0" hangingPunct="1">
         <a:spcBef>
           <a:spcPct val="0"/>
         </a:spcBef>
         <a:buNone/>
-        <a:defRPr sz="2700" b="1" kern="1200" baseline="0">
+        <a:defRPr sz="2000" b="1" kern="1200" baseline="0">
           <a:solidFill>
             <a:schemeClr val="tx1"/>
           </a:solidFill>
@@ -3985,16 +3985,16 @@
       </a:lvl1pPr>
     </p:titleStyle>
     <p:bodyStyle>
-      <a:lvl1pPr marL="228600" indent="-228600" algn="l" defTabSz="457200" rtl="0" eaLnBrk="1" latinLnBrk="0" hangingPunct="1">
+      <a:lvl1pPr marL="171450" indent="-171450" algn="l" defTabSz="342900" rtl="0" eaLnBrk="1" latinLnBrk="0" hangingPunct="1">
         <a:lnSpc>
           <a:spcPct val="100000"/>
         </a:lnSpc>
         <a:spcBef>
-          <a:spcPts val="800"/>
+          <a:spcPts val="600"/>
         </a:spcBef>
         <a:buFont typeface="Arial"/>
         <a:buChar char="•"/>
-        <a:defRPr sz="1600" kern="1200">
+        <a:defRPr sz="1200" kern="1200">
           <a:solidFill>
             <a:schemeClr val="tx1"/>
           </a:solidFill>
@@ -4003,16 +4003,16 @@
           <a:cs typeface="+mn-cs"/>
         </a:defRPr>
       </a:lvl1pPr>
-      <a:lvl2pPr marL="457200" indent="-228600" algn="l" defTabSz="457200" rtl="0" eaLnBrk="1" latinLnBrk="0" hangingPunct="1">
+      <a:lvl2pPr marL="342900" indent="-171450" algn="l" defTabSz="342900" rtl="0" eaLnBrk="1" latinLnBrk="0" hangingPunct="1">
         <a:lnSpc>
           <a:spcPct val="100000"/>
         </a:lnSpc>
         <a:spcBef>
-          <a:spcPts val="480"/>
+          <a:spcPts val="360"/>
         </a:spcBef>
         <a:buFont typeface="Wingdings"/>
         <a:buChar char="§"/>
-        <a:defRPr sz="1500" kern="1200">
+        <a:defRPr sz="1100" kern="1200">
           <a:solidFill>
             <a:schemeClr val="tx1"/>
           </a:solidFill>
@@ -4021,16 +4021,16 @@
           <a:cs typeface="+mn-cs"/>
         </a:defRPr>
       </a:lvl2pPr>
-      <a:lvl3pPr marL="685800" indent="-228600" algn="l" defTabSz="457200" rtl="0" eaLnBrk="1" latinLnBrk="0" hangingPunct="1">
+      <a:lvl3pPr marL="514350" indent="-171450" algn="l" defTabSz="342900" rtl="0" eaLnBrk="1" latinLnBrk="0" hangingPunct="1">
         <a:lnSpc>
           <a:spcPct val="100000"/>
         </a:lnSpc>
         <a:spcBef>
-          <a:spcPts val="480"/>
+          <a:spcPts val="360"/>
         </a:spcBef>
         <a:buFont typeface="Courier New"/>
         <a:buChar char="o"/>
-        <a:defRPr sz="1300" kern="1200">
+        <a:defRPr sz="1000" kern="1200">
           <a:solidFill>
             <a:schemeClr val="tx1"/>
           </a:solidFill>
@@ -4039,16 +4039,16 @@
           <a:cs typeface="+mn-cs"/>
         </a:defRPr>
       </a:lvl3pPr>
-      <a:lvl4pPr marL="914400" indent="-228600" algn="l" defTabSz="457200" rtl="0" eaLnBrk="1" latinLnBrk="0" hangingPunct="1">
+      <a:lvl4pPr marL="685800" indent="-171450" algn="l" defTabSz="342900" rtl="0" eaLnBrk="1" latinLnBrk="0" hangingPunct="1">
         <a:lnSpc>
           <a:spcPct val="100000"/>
         </a:lnSpc>
         <a:spcBef>
-          <a:spcPts val="480"/>
+          <a:spcPts val="360"/>
         </a:spcBef>
         <a:buFont typeface="Arial"/>
         <a:buChar char="–"/>
-        <a:defRPr sz="1200" kern="1200">
+        <a:defRPr sz="900" kern="1200">
           <a:solidFill>
             <a:schemeClr val="tx1"/>
           </a:solidFill>
@@ -4057,16 +4057,16 @@
           <a:cs typeface="+mn-cs"/>
         </a:defRPr>
       </a:lvl4pPr>
-      <a:lvl5pPr marL="1143000" indent="-228600" algn="l" defTabSz="457200" rtl="0" eaLnBrk="1" latinLnBrk="0" hangingPunct="1">
+      <a:lvl5pPr marL="857250" indent="-171450" algn="l" defTabSz="342900" rtl="0" eaLnBrk="1" latinLnBrk="0" hangingPunct="1">
         <a:lnSpc>
           <a:spcPct val="100000"/>
         </a:lnSpc>
         <a:spcBef>
-          <a:spcPts val="480"/>
+          <a:spcPts val="360"/>
         </a:spcBef>
         <a:buFont typeface="Arial"/>
         <a:buChar char="»"/>
-        <a:defRPr sz="1100" kern="1200">
+        <a:defRPr sz="800" kern="1200">
           <a:solidFill>
             <a:schemeClr val="tx1"/>
           </a:solidFill>
@@ -4075,32 +4075,32 @@
           <a:cs typeface="+mn-cs"/>
         </a:defRPr>
       </a:lvl5pPr>
-      <a:lvl6pPr marL="1371600" indent="-228600" algn="l">
-        <a:defRPr sz="1100" kern="1200">
+      <a:lvl6pPr marL="1028700" indent="-171450" algn="l">
+        <a:defRPr sz="800" kern="1200">
           <a:solidFill>
             <a:schemeClr val="tx1"/>
           </a:solidFill>
           <a:latin typeface="+mn-lt"/>
         </a:defRPr>
       </a:lvl6pPr>
-      <a:lvl7pPr marL="1600200" indent="-228600" algn="l">
-        <a:defRPr sz="1100" kern="1200">
+      <a:lvl7pPr marL="1200150" indent="-171450" algn="l">
+        <a:defRPr sz="800" kern="1200">
           <a:solidFill>
             <a:schemeClr val="tx1"/>
           </a:solidFill>
           <a:latin typeface="+mn-lt"/>
         </a:defRPr>
       </a:lvl7pPr>
-      <a:lvl8pPr marL="1828800" indent="-228600" algn="l">
-        <a:defRPr sz="1100" kern="1200">
+      <a:lvl8pPr marL="1371600" indent="-171450" algn="l">
+        <a:defRPr sz="800" kern="1200">
           <a:solidFill>
             <a:schemeClr val="tx1"/>
           </a:solidFill>
           <a:latin typeface="+mn-lt"/>
         </a:defRPr>
       </a:lvl8pPr>
-      <a:lvl9pPr marL="2057400" indent="-228600" algn="l">
-        <a:defRPr sz="1100" kern="1200">
+      <a:lvl9pPr marL="1543050" indent="-171450" algn="l">
+        <a:defRPr sz="800" kern="1200">
           <a:solidFill>
             <a:schemeClr val="tx1"/>
           </a:solidFill>
@@ -4112,8 +4112,8 @@
       <a:defPPr>
         <a:defRPr lang="en-US"/>
       </a:defPPr>
-      <a:lvl1pPr marL="0" algn="l" defTabSz="457200">
-        <a:defRPr sz="1300" kern="1200">
+      <a:lvl1pPr marL="0" algn="l" defTabSz="342900">
+        <a:defRPr sz="1000" kern="1200">
           <a:solidFill>
             <a:schemeClr val="tx1"/>
           </a:solidFill>
@@ -4122,8 +4122,8 @@
           <a:cs typeface="+mn-cs"/>
         </a:defRPr>
       </a:lvl1pPr>
-      <a:lvl2pPr marL="457200" algn="l" defTabSz="457200">
-        <a:defRPr sz="1300" kern="1200">
+      <a:lvl2pPr marL="342900" algn="l" defTabSz="342900">
+        <a:defRPr sz="1000" kern="1200">
           <a:solidFill>
             <a:schemeClr val="tx1"/>
           </a:solidFill>
@@ -4132,8 +4132,8 @@
           <a:cs typeface="+mn-cs"/>
         </a:defRPr>
       </a:lvl2pPr>
-      <a:lvl3pPr marL="914400" algn="l" defTabSz="457200">
-        <a:defRPr sz="1300" kern="1200">
+      <a:lvl3pPr marL="685800" algn="l" defTabSz="342900">
+        <a:defRPr sz="1000" kern="1200">
           <a:solidFill>
             <a:schemeClr val="tx1"/>
           </a:solidFill>
@@ -4142,8 +4142,8 @@
           <a:cs typeface="+mn-cs"/>
         </a:defRPr>
       </a:lvl3pPr>
-      <a:lvl4pPr marL="1371600" algn="l" defTabSz="457200">
-        <a:defRPr sz="1300" kern="1200">
+      <a:lvl4pPr marL="1028700" algn="l" defTabSz="342900">
+        <a:defRPr sz="1000" kern="1200">
           <a:solidFill>
             <a:schemeClr val="tx1"/>
           </a:solidFill>
@@ -4152,8 +4152,8 @@
           <a:cs typeface="+mn-cs"/>
         </a:defRPr>
       </a:lvl4pPr>
-      <a:lvl5pPr marL="1828800" algn="l" defTabSz="457200">
-        <a:defRPr sz="1300" kern="1200">
+      <a:lvl5pPr marL="1371600" algn="l" defTabSz="342900">
+        <a:defRPr sz="1000" kern="1200">
           <a:solidFill>
             <a:schemeClr val="tx1"/>
           </a:solidFill>
@@ -4162,8 +4162,8 @@
           <a:cs typeface="+mn-cs"/>
         </a:defRPr>
       </a:lvl5pPr>
-      <a:lvl6pPr marL="2286000" algn="l" defTabSz="457200">
-        <a:defRPr sz="1300" kern="1200">
+      <a:lvl6pPr marL="1714500" algn="l" defTabSz="342900">
+        <a:defRPr sz="1000" kern="1200">
           <a:solidFill>
             <a:schemeClr val="tx1"/>
           </a:solidFill>
@@ -4172,8 +4172,8 @@
           <a:cs typeface="+mn-cs"/>
         </a:defRPr>
       </a:lvl6pPr>
-      <a:lvl7pPr marL="2743200" algn="l" defTabSz="457200">
-        <a:defRPr sz="1300" kern="1200">
+      <a:lvl7pPr marL="2057400" algn="l" defTabSz="342900">
+        <a:defRPr sz="1000" kern="1200">
           <a:solidFill>
             <a:schemeClr val="tx1"/>
           </a:solidFill>
@@ -4182,8 +4182,8 @@
           <a:cs typeface="+mn-cs"/>
         </a:defRPr>
       </a:lvl7pPr>
-      <a:lvl8pPr marL="3200400" algn="l" defTabSz="457200">
-        <a:defRPr sz="1300" kern="1200">
+      <a:lvl8pPr marL="2400300" algn="l" defTabSz="342900">
+        <a:defRPr sz="1000" kern="1200">
           <a:solidFill>
             <a:schemeClr val="tx1"/>
           </a:solidFill>
@@ -4192,8 +4192,8 @@
           <a:cs typeface="+mn-cs"/>
         </a:defRPr>
       </a:lvl8pPr>
-      <a:lvl9pPr marL="3657600" algn="l" defTabSz="457200">
-        <a:defRPr sz="1300" kern="1200">
+      <a:lvl9pPr marL="2743200" algn="l" defTabSz="342900">
+        <a:defRPr sz="1000" kern="1200">
           <a:solidFill>
             <a:schemeClr val="tx1"/>
           </a:solidFill>

</xml_diff>